<commit_message>
feat: module05/learning implementando os exercios 30,31,32,33,34
</commit_message>
<xml_diff>
--- a/src/module05/content/OOP-Part1-Heranca-Java.pptx
+++ b/src/module05/content/OOP-Part1-Heranca-Java.pptx
@@ -4,6 +4,9 @@
   <p:sldMasterIdLst>
     <p:sldMasterId id="2147483648" r:id="rId1"/>
   </p:sldMasterIdLst>
+  <p:notesMasterIdLst>
+    <p:notesMasterId r:id="rId33"/>
+  </p:notesMasterIdLst>
   <p:sldIdLst>
     <p:sldId id="256" r:id="rId2"/>
     <p:sldId id="257" r:id="rId3"/>
@@ -37,10 +40,7 @@
     <p:sldId id="285" r:id="rId31"/>
     <p:sldId id="286" r:id="rId32"/>
   </p:sldIdLst>
-  <p:notesMasterIdLst>
-    <p:notesMasterId r:id="rId33"/>
-  </p:notesMasterIdLst>
-  <p:sldSz cx="9144000" cy="5143500"/>
+  <p:sldSz cx="9144000" cy="5143500" type="screen16x9"/>
   <p:notesSz cx="5143500" cy="9144000"/>
   <p:defaultTextStyle>
     <a:lvl1pPr marL="0" algn="l" defTabSz="914400" rtl="0" eaLnBrk="1" latinLnBrk="0" hangingPunct="1">
@@ -134,6 +134,11 @@
       </a:defRPr>
     </a:lvl9pPr>
   </p:defaultTextStyle>
+  <p:extLst>
+    <p:ext uri="{EFAFB233-063F-42B5-8137-9DF3F51BA10A}">
+      <p15:sldGuideLst xmlns:p15="http://schemas.microsoft.com/office/powerpoint/2012/main"/>
+    </p:ext>
+  </p:extLst>
 </p:presentation>
 </file>
 
@@ -159,234 +164,10 @@
           <a:chExt cx="0" cy="0"/>
         </a:xfrm>
       </p:grpSpPr>
-      <p:sp>
-        <p:nvSpPr>
-          <p:cNvPr id="2" name="Header Placeholder 1"/>
-          <p:cNvSpPr>
-            <a:spLocks noGrp="1"/>
-          </p:cNvSpPr>
-          <p:nvPr>
-            <p:ph type="hdr" sz="quarter"/>
-          </p:nvPr>
-        </p:nvSpPr>
-        <p:spPr>
-          <a:xfrm>
-            <a:off x="0" y="0"/>
-            <a:ext cx="2971800" cy="458788"/>
-          </a:xfrm>
-          <a:prstGeom prst="rect">
-            <a:avLst/>
-          </a:prstGeom>
-        </p:spPr>
-        <p:txBody>
-          <a:bodyPr vert="horz" lIns="91440" tIns="45720" rIns="91440" bIns="45720" rtlCol="0"/>
-          <a:lstStyle>
-            <a:lvl1pPr algn="l">
-              <a:defRPr sz="1200"/>
-            </a:lvl1pPr>
-          </a:lstStyle>
-          <a:p>
-            <a:endParaRPr lang="en-US"/>
-          </a:p>
-        </p:txBody>
-      </p:sp>
-      <p:sp>
-        <p:nvSpPr>
-          <p:cNvPr id="3" name="Date Placeholder 2"/>
-          <p:cNvSpPr>
-            <a:spLocks noGrp="1"/>
-          </p:cNvSpPr>
-          <p:nvPr>
-            <p:ph type="dt" idx="1"/>
-          </p:nvPr>
-        </p:nvSpPr>
-        <p:spPr>
-          <a:xfrm>
-            <a:off x="3884613" y="0"/>
-            <a:ext cx="2971800" cy="458788"/>
-          </a:xfrm>
-          <a:prstGeom prst="rect">
-            <a:avLst/>
-          </a:prstGeom>
-        </p:spPr>
-        <p:txBody>
-          <a:bodyPr vert="horz" lIns="91440" tIns="45720" rIns="91440" bIns="45720" rtlCol="0"/>
-          <a:lstStyle>
-            <a:lvl1pPr algn="r">
-              <a:defRPr sz="1200"/>
-            </a:lvl1pPr>
-          </a:lstStyle>
-          <a:p>
-            <a:fld id="{5282F153-3F37-0F45-9E97-73ACFA13230C}" type="datetimeFigureOut">
-              <a:rPr lang="en-US"/>
-              <a:t>7/23/19</a:t>
-            </a:fld>
-            <a:endParaRPr lang="en-US"/>
-          </a:p>
-        </p:txBody>
-      </p:sp>
-      <p:sp>
-        <p:nvSpPr>
-          <p:cNvPr id="4" name="Slide Image Placeholder 3"/>
-          <p:cNvSpPr>
-            <a:spLocks noGrp="1" noRot="1" noChangeAspect="1"/>
-          </p:cNvSpPr>
-          <p:nvPr>
-            <p:ph type="sldImg" idx="2"/>
-          </p:nvPr>
-        </p:nvSpPr>
-        <p:spPr>
-          <a:xfrm>
-            <a:off x="685800" y="1143000"/>
-            <a:ext cx="5486400" cy="3086100"/>
-          </a:xfrm>
-          <a:prstGeom prst="rect">
-            <a:avLst/>
-          </a:prstGeom>
-          <a:noFill/>
-          <a:ln w="12700">
-            <a:solidFill>
-              <a:prstClr val="black"/>
-            </a:solidFill>
-          </a:ln>
-        </p:spPr>
-        <p:txBody>
-          <a:bodyPr vert="horz" lIns="91440" tIns="45720" rIns="91440" bIns="45720" rtlCol="0" anchor="ctr"/>
-          <a:lstStyle/>
-          <a:p>
-            <a:endParaRPr lang="en-US"/>
-          </a:p>
-        </p:txBody>
-      </p:sp>
-      <p:sp>
-        <p:nvSpPr>
-          <p:cNvPr id="5" name="Notes Placeholder 4"/>
-          <p:cNvSpPr>
-            <a:spLocks noGrp="1"/>
-          </p:cNvSpPr>
-          <p:nvPr>
-            <p:ph type="body" sz="quarter" idx="3"/>
-          </p:nvPr>
-        </p:nvSpPr>
-        <p:spPr>
-          <a:xfrm>
-            <a:off x="685800" y="4400550"/>
-            <a:ext cx="5486400" cy="3600450"/>
-          </a:xfrm>
-          <a:prstGeom prst="rect">
-            <a:avLst/>
-          </a:prstGeom>
-        </p:spPr>
-        <p:txBody>
-          <a:bodyPr vert="horz" lIns="91440" tIns="45720" rIns="91440" bIns="45720" rtlCol="0"/>
-          <a:lstStyle/>
-          <a:p>
-            <a:pPr lvl="0"/>
-            <a:r>
-              <a:rPr lang="en-US"/>
-              <a:t>Click to edit Master text styles</a:t>
-            </a:r>
-          </a:p>
-          <a:p>
-            <a:pPr lvl="1"/>
-            <a:r>
-              <a:rPr lang="en-US"/>
-              <a:t>Second level</a:t>
-            </a:r>
-          </a:p>
-          <a:p>
-            <a:pPr lvl="2"/>
-            <a:r>
-              <a:rPr lang="en-US"/>
-              <a:t>Third level</a:t>
-            </a:r>
-          </a:p>
-          <a:p>
-            <a:pPr lvl="3"/>
-            <a:r>
-              <a:rPr lang="en-US"/>
-              <a:t>Fourth level</a:t>
-            </a:r>
-          </a:p>
-          <a:p>
-            <a:pPr lvl="4"/>
-            <a:r>
-              <a:rPr lang="en-US"/>
-              <a:t>Fifth level</a:t>
-            </a:r>
-          </a:p>
-        </p:txBody>
-      </p:sp>
-      <p:sp>
-        <p:nvSpPr>
-          <p:cNvPr id="6" name="Footer Placeholder 5"/>
-          <p:cNvSpPr>
-            <a:spLocks noGrp="1"/>
-          </p:cNvSpPr>
-          <p:nvPr>
-            <p:ph type="ftr" sz="quarter" idx="4"/>
-          </p:nvPr>
-        </p:nvSpPr>
-        <p:spPr>
-          <a:xfrm>
-            <a:off x="0" y="8685213"/>
-            <a:ext cx="2971800" cy="458787"/>
-          </a:xfrm>
-          <a:prstGeom prst="rect">
-            <a:avLst/>
-          </a:prstGeom>
-        </p:spPr>
-        <p:txBody>
-          <a:bodyPr vert="horz" lIns="91440" tIns="45720" rIns="91440" bIns="45720" rtlCol="0" anchor="b"/>
-          <a:lstStyle>
-            <a:lvl1pPr algn="l">
-              <a:defRPr sz="1200"/>
-            </a:lvl1pPr>
-          </a:lstStyle>
-          <a:p>
-            <a:endParaRPr lang="en-US"/>
-          </a:p>
-        </p:txBody>
-      </p:sp>
-      <p:sp>
-        <p:nvSpPr>
-          <p:cNvPr id="7" name="Slide Number Placeholder 6"/>
-          <p:cNvSpPr>
-            <a:spLocks noGrp="1"/>
-          </p:cNvSpPr>
-          <p:nvPr>
-            <p:ph type="sldNum" sz="quarter" idx="5"/>
-          </p:nvPr>
-        </p:nvSpPr>
-        <p:spPr>
-          <a:xfrm>
-            <a:off x="3884613" y="8685213"/>
-            <a:ext cx="2971800" cy="458787"/>
-          </a:xfrm>
-          <a:prstGeom prst="rect">
-            <a:avLst/>
-          </a:prstGeom>
-        </p:spPr>
-        <p:txBody>
-          <a:bodyPr vert="horz" lIns="91440" tIns="45720" rIns="91440" bIns="45720" rtlCol="0" anchor="b"/>
-          <a:lstStyle>
-            <a:lvl1pPr algn="r">
-              <a:defRPr sz="1200"/>
-            </a:lvl1pPr>
-          </a:lstStyle>
-          <a:p>
-            <a:fld id="{CE5E9CC1-C706-0F49-92D6-E571CC5EEA8F}" type="slidenum">
-              <a:rPr lang="en-US"/>
-              <a:t>‹#›</a:t>
-            </a:fld>
-            <a:endParaRPr lang="en-US"/>
-          </a:p>
-        </p:txBody>
-      </p:sp>
     </p:spTree>
     <p:extLst>
       <p:ext uri="{BB962C8B-B14F-4D97-AF65-F5344CB8AC3E}">
-        <p14:creationId xmlns:p14="http://schemas.microsoft.com/office/powerpoint/2010/main" val="1024086991"/>
+        <p14:creationId xmlns:p14="http://schemas.microsoft.com/office/powerpoint/2010/main" val="2398323207"/>
       </p:ext>
     </p:extLst>
   </p:cSld>
@@ -530,10 +311,6 @@
           <a:bodyPr/>
           <a:lstStyle/>
           <a:p>
-            <a:r>
-              <a:rPr lang="en-US" dirty="0"/>
-              <a:t/>
-            </a:r>
             <a:endParaRPr lang="en-US" dirty="0"/>
           </a:p>
         </p:txBody>
@@ -618,10 +395,6 @@
           <a:bodyPr/>
           <a:lstStyle/>
           <a:p>
-            <a:r>
-              <a:rPr lang="en-US" dirty="0"/>
-              <a:t/>
-            </a:r>
             <a:endParaRPr lang="en-US" dirty="0"/>
           </a:p>
         </p:txBody>
@@ -706,10 +479,6 @@
           <a:bodyPr/>
           <a:lstStyle/>
           <a:p>
-            <a:r>
-              <a:rPr lang="en-US" dirty="0"/>
-              <a:t/>
-            </a:r>
             <a:endParaRPr lang="en-US" dirty="0"/>
           </a:p>
         </p:txBody>
@@ -794,10 +563,6 @@
           <a:bodyPr/>
           <a:lstStyle/>
           <a:p>
-            <a:r>
-              <a:rPr lang="en-US" dirty="0"/>
-              <a:t/>
-            </a:r>
             <a:endParaRPr lang="en-US" dirty="0"/>
           </a:p>
         </p:txBody>
@@ -882,10 +647,6 @@
           <a:bodyPr/>
           <a:lstStyle/>
           <a:p>
-            <a:r>
-              <a:rPr lang="en-US" dirty="0"/>
-              <a:t/>
-            </a:r>
             <a:endParaRPr lang="en-US" dirty="0"/>
           </a:p>
         </p:txBody>
@@ -970,10 +731,6 @@
           <a:bodyPr/>
           <a:lstStyle/>
           <a:p>
-            <a:r>
-              <a:rPr lang="en-US" dirty="0"/>
-              <a:t/>
-            </a:r>
             <a:endParaRPr lang="en-US" dirty="0"/>
           </a:p>
         </p:txBody>
@@ -1058,10 +815,6 @@
           <a:bodyPr/>
           <a:lstStyle/>
           <a:p>
-            <a:r>
-              <a:rPr lang="en-US" dirty="0"/>
-              <a:t/>
-            </a:r>
             <a:endParaRPr lang="en-US" dirty="0"/>
           </a:p>
         </p:txBody>
@@ -1146,10 +899,6 @@
           <a:bodyPr/>
           <a:lstStyle/>
           <a:p>
-            <a:r>
-              <a:rPr lang="en-US" dirty="0"/>
-              <a:t/>
-            </a:r>
             <a:endParaRPr lang="en-US" dirty="0"/>
           </a:p>
         </p:txBody>
@@ -1234,10 +983,6 @@
           <a:bodyPr/>
           <a:lstStyle/>
           <a:p>
-            <a:r>
-              <a:rPr lang="en-US" dirty="0"/>
-              <a:t/>
-            </a:r>
             <a:endParaRPr lang="en-US" dirty="0"/>
           </a:p>
         </p:txBody>
@@ -1322,10 +1067,6 @@
           <a:bodyPr/>
           <a:lstStyle/>
           <a:p>
-            <a:r>
-              <a:rPr lang="en-US" dirty="0"/>
-              <a:t/>
-            </a:r>
             <a:endParaRPr lang="en-US" dirty="0"/>
           </a:p>
         </p:txBody>
@@ -1410,10 +1151,6 @@
           <a:bodyPr/>
           <a:lstStyle/>
           <a:p>
-            <a:r>
-              <a:rPr lang="en-US" dirty="0"/>
-              <a:t/>
-            </a:r>
             <a:endParaRPr lang="en-US" dirty="0"/>
           </a:p>
         </p:txBody>
@@ -1498,10 +1235,6 @@
           <a:bodyPr/>
           <a:lstStyle/>
           <a:p>
-            <a:r>
-              <a:rPr lang="en-US" dirty="0"/>
-              <a:t/>
-            </a:r>
             <a:endParaRPr lang="en-US" dirty="0"/>
           </a:p>
         </p:txBody>
@@ -1586,10 +1319,6 @@
           <a:bodyPr/>
           <a:lstStyle/>
           <a:p>
-            <a:r>
-              <a:rPr lang="en-US" dirty="0"/>
-              <a:t/>
-            </a:r>
             <a:endParaRPr lang="en-US" dirty="0"/>
           </a:p>
         </p:txBody>
@@ -1674,10 +1403,6 @@
           <a:bodyPr/>
           <a:lstStyle/>
           <a:p>
-            <a:r>
-              <a:rPr lang="en-US" dirty="0"/>
-              <a:t/>
-            </a:r>
             <a:endParaRPr lang="en-US" dirty="0"/>
           </a:p>
         </p:txBody>
@@ -1762,10 +1487,6 @@
           <a:bodyPr/>
           <a:lstStyle/>
           <a:p>
-            <a:r>
-              <a:rPr lang="en-US" dirty="0"/>
-              <a:t/>
-            </a:r>
             <a:endParaRPr lang="en-US" dirty="0"/>
           </a:p>
         </p:txBody>
@@ -1850,10 +1571,6 @@
           <a:bodyPr/>
           <a:lstStyle/>
           <a:p>
-            <a:r>
-              <a:rPr lang="en-US" dirty="0"/>
-              <a:t/>
-            </a:r>
             <a:endParaRPr lang="en-US" dirty="0"/>
           </a:p>
         </p:txBody>
@@ -1938,10 +1655,6 @@
           <a:bodyPr/>
           <a:lstStyle/>
           <a:p>
-            <a:r>
-              <a:rPr lang="en-US" dirty="0"/>
-              <a:t/>
-            </a:r>
             <a:endParaRPr lang="en-US" dirty="0"/>
           </a:p>
         </p:txBody>
@@ -2026,10 +1739,6 @@
           <a:bodyPr/>
           <a:lstStyle/>
           <a:p>
-            <a:r>
-              <a:rPr lang="en-US" dirty="0"/>
-              <a:t/>
-            </a:r>
             <a:endParaRPr lang="en-US" dirty="0"/>
           </a:p>
         </p:txBody>
@@ -2114,10 +1823,6 @@
           <a:bodyPr/>
           <a:lstStyle/>
           <a:p>
-            <a:r>
-              <a:rPr lang="en-US" dirty="0"/>
-              <a:t/>
-            </a:r>
             <a:endParaRPr lang="en-US" dirty="0"/>
           </a:p>
         </p:txBody>
@@ -2202,10 +1907,6 @@
           <a:bodyPr/>
           <a:lstStyle/>
           <a:p>
-            <a:r>
-              <a:rPr lang="en-US" dirty="0"/>
-              <a:t/>
-            </a:r>
             <a:endParaRPr lang="en-US" dirty="0"/>
           </a:p>
         </p:txBody>
@@ -2290,10 +1991,6 @@
           <a:bodyPr/>
           <a:lstStyle/>
           <a:p>
-            <a:r>
-              <a:rPr lang="en-US" dirty="0"/>
-              <a:t/>
-            </a:r>
             <a:endParaRPr lang="en-US" dirty="0"/>
           </a:p>
         </p:txBody>
@@ -2378,10 +2075,6 @@
           <a:bodyPr/>
           <a:lstStyle/>
           <a:p>
-            <a:r>
-              <a:rPr lang="en-US" dirty="0"/>
-              <a:t/>
-            </a:r>
             <a:endParaRPr lang="en-US" dirty="0"/>
           </a:p>
         </p:txBody>
@@ -2466,10 +2159,6 @@
           <a:bodyPr/>
           <a:lstStyle/>
           <a:p>
-            <a:r>
-              <a:rPr lang="en-US" dirty="0"/>
-              <a:t/>
-            </a:r>
             <a:endParaRPr lang="en-US" dirty="0"/>
           </a:p>
         </p:txBody>
@@ -2554,10 +2243,6 @@
           <a:bodyPr/>
           <a:lstStyle/>
           <a:p>
-            <a:r>
-              <a:rPr lang="en-US" dirty="0"/>
-              <a:t/>
-            </a:r>
             <a:endParaRPr lang="en-US" dirty="0"/>
           </a:p>
         </p:txBody>
@@ -2642,10 +2327,6 @@
           <a:bodyPr/>
           <a:lstStyle/>
           <a:p>
-            <a:r>
-              <a:rPr lang="en-US" dirty="0"/>
-              <a:t/>
-            </a:r>
             <a:endParaRPr lang="en-US" dirty="0"/>
           </a:p>
         </p:txBody>
@@ -2730,10 +2411,6 @@
           <a:bodyPr/>
           <a:lstStyle/>
           <a:p>
-            <a:r>
-              <a:rPr lang="en-US" dirty="0"/>
-              <a:t/>
-            </a:r>
             <a:endParaRPr lang="en-US" dirty="0"/>
           </a:p>
         </p:txBody>
@@ -2818,10 +2495,6 @@
           <a:bodyPr/>
           <a:lstStyle/>
           <a:p>
-            <a:r>
-              <a:rPr lang="en-US" dirty="0"/>
-              <a:t/>
-            </a:r>
             <a:endParaRPr lang="en-US" dirty="0"/>
           </a:p>
         </p:txBody>
@@ -2906,10 +2579,6 @@
           <a:bodyPr/>
           <a:lstStyle/>
           <a:p>
-            <a:r>
-              <a:rPr lang="en-US" dirty="0"/>
-              <a:t/>
-            </a:r>
             <a:endParaRPr lang="en-US" dirty="0"/>
           </a:p>
         </p:txBody>
@@ -2994,10 +2663,6 @@
           <a:bodyPr/>
           <a:lstStyle/>
           <a:p>
-            <a:r>
-              <a:rPr lang="en-US" dirty="0"/>
-              <a:t/>
-            </a:r>
             <a:endParaRPr lang="en-US" dirty="0"/>
           </a:p>
         </p:txBody>
@@ -3082,10 +2747,6 @@
           <a:bodyPr/>
           <a:lstStyle/>
           <a:p>
-            <a:r>
-              <a:rPr lang="en-US" dirty="0"/>
-              <a:t/>
-            </a:r>
             <a:endParaRPr lang="en-US" dirty="0"/>
           </a:p>
         </p:txBody>
@@ -3170,10 +2831,6 @@
           <a:bodyPr/>
           <a:lstStyle/>
           <a:p>
-            <a:r>
-              <a:rPr lang="en-US" dirty="0"/>
-              <a:t/>
-            </a:r>
             <a:endParaRPr lang="en-US" dirty="0"/>
           </a:p>
         </p:txBody>
@@ -3247,6 +2904,11 @@
 <file path=ppt/slideMasters/slideMaster1.xml><?xml version="1.0" encoding="utf-8"?>
 <p:sldMaster xmlns:a="http://schemas.openxmlformats.org/drawingml/2006/main" xmlns:r="http://schemas.openxmlformats.org/officeDocument/2006/relationships" xmlns:p="http://schemas.openxmlformats.org/presentationml/2006/main">
   <p:cSld>
+    <p:bg>
+      <p:bgRef idx="1001">
+        <a:schemeClr val="bg1"/>
+      </p:bgRef>
+    </p:bg>
     <p:spTree>
       <p:nvGrpSpPr>
         <p:cNvPr id="1" name=""/>
@@ -3529,6 +3191,7 @@
         <a:solidFill>
           <a:srgbClr val="1A3A2A"/>
         </a:solidFill>
+        <a:effectLst/>
       </p:bgPr>
     </p:bg>
     <p:spTree>
@@ -3566,11 +3229,11 @@
           <a:bodyPr wrap="square" rtlCol="0" anchor="ctr"/>
           <a:lstStyle/>
           <a:p>
-            <a:pPr indent="0" marL="0">
-              <a:buNone/>
-            </a:pPr>
-            <a:r>
-              <a:rPr lang="en-US" sz="1000" b="1" spc="400" kern="0" dirty="0">
+            <a:pPr marL="0" indent="0">
+              <a:buNone/>
+            </a:pPr>
+            <a:r>
+              <a:rPr lang="en-US" sz="1000" b="1" kern="0" spc="400" dirty="0">
                 <a:solidFill>
                   <a:srgbClr val="2ECC71"/>
                 </a:solidFill>
@@ -3605,7 +3268,7 @@
           <a:bodyPr wrap="square" rtlCol="0" anchor="ctr"/>
           <a:lstStyle/>
           <a:p>
-            <a:pPr indent="0" marL="0">
+            <a:pPr marL="0" indent="0">
               <a:buNone/>
             </a:pPr>
             <a:r>
@@ -3622,7 +3285,7 @@
             <a:endParaRPr lang="en-US" sz="4600" dirty="0"/>
           </a:p>
           <a:p>
-            <a:pPr indent="0" marL="0">
+            <a:pPr marL="0" indent="0">
               <a:buNone/>
             </a:pPr>
             <a:r>
@@ -3639,7 +3302,7 @@
             <a:endParaRPr lang="en-US" sz="4600" dirty="0"/>
           </a:p>
           <a:p>
-            <a:pPr indent="0" marL="0">
+            <a:pPr marL="0" indent="0">
               <a:buNone/>
             </a:pPr>
             <a:r>
@@ -3678,7 +3341,7 @@
           <a:bodyPr wrap="square" rtlCol="0" anchor="ctr"/>
           <a:lstStyle/>
           <a:p>
-            <a:pPr indent="0" marL="0">
+            <a:pPr marL="0" indent="0">
               <a:buNone/>
             </a:pPr>
             <a:r>
@@ -3717,7 +3380,7 @@
           <a:bodyPr wrap="square" rtlCol="0" anchor="ctr"/>
           <a:lstStyle/>
           <a:p>
-            <a:pPr indent="0" marL="0">
+            <a:pPr marL="0" indent="0">
               <a:buNone/>
             </a:pPr>
             <a:r>
@@ -3783,7 +3446,7 @@
           <a:bodyPr wrap="square" rtlCol="0" anchor="ctr"/>
           <a:lstStyle/>
           <a:p>
-            <a:pPr algn="ctr" indent="0" marL="0">
+            <a:pPr marL="0" indent="0" algn="ctr">
               <a:buNone/>
             </a:pPr>
             <a:r>
@@ -3849,7 +3512,7 @@
           <a:bodyPr wrap="square" rtlCol="0" anchor="ctr"/>
           <a:lstStyle/>
           <a:p>
-            <a:pPr algn="ctr" indent="0" marL="0">
+            <a:pPr marL="0" indent="0" algn="ctr">
               <a:buNone/>
             </a:pPr>
             <a:r>
@@ -3915,7 +3578,7 @@
           <a:bodyPr wrap="square" rtlCol="0" anchor="ctr"/>
           <a:lstStyle/>
           <a:p>
-            <a:pPr algn="ctr" indent="0" marL="0">
+            <a:pPr marL="0" indent="0" algn="ctr">
               <a:buNone/>
             </a:pPr>
             <a:r>
@@ -3981,7 +3644,7 @@
           <a:bodyPr wrap="square" rtlCol="0" anchor="ctr"/>
           <a:lstStyle/>
           <a:p>
-            <a:pPr algn="ctr" indent="0" marL="0">
+            <a:pPr marL="0" indent="0" algn="ctr">
               <a:buNone/>
             </a:pPr>
             <a:r>
@@ -4047,7 +3710,7 @@
           <a:bodyPr wrap="square" rtlCol="0" anchor="ctr"/>
           <a:lstStyle/>
           <a:p>
-            <a:pPr algn="ctr" indent="0" marL="0">
+            <a:pPr marL="0" indent="0" algn="ctr">
               <a:buNone/>
             </a:pPr>
             <a:r>
@@ -4113,7 +3776,7 @@
           <a:bodyPr wrap="square" rtlCol="0" anchor="ctr"/>
           <a:lstStyle/>
           <a:p>
-            <a:pPr algn="ctr" indent="0" marL="0">
+            <a:pPr marL="0" indent="0" algn="ctr">
               <a:buNone/>
             </a:pPr>
             <a:r>
@@ -4179,7 +3842,7 @@
           <a:bodyPr wrap="square" rtlCol="0" anchor="ctr"/>
           <a:lstStyle/>
           <a:p>
-            <a:pPr algn="ctr" indent="0" marL="0">
+            <a:pPr marL="0" indent="0" algn="ctr">
               <a:buNone/>
             </a:pPr>
             <a:r>
@@ -4245,7 +3908,7 @@
           <a:bodyPr wrap="square" rtlCol="0" anchor="ctr"/>
           <a:lstStyle/>
           <a:p>
-            <a:pPr algn="ctr" indent="0" marL="0">
+            <a:pPr marL="0" indent="0" algn="ctr">
               <a:buNone/>
             </a:pPr>
             <a:r>
@@ -4354,6 +4017,7 @@
         <a:solidFill>
           <a:srgbClr val="1A3A2A"/>
         </a:solidFill>
+        <a:effectLst/>
       </p:bgPr>
     </p:bg>
     <p:spTree>
@@ -4391,7 +4055,7 @@
           <a:bodyPr wrap="square" rtlCol="0" anchor="ctr"/>
           <a:lstStyle/>
           <a:p>
-            <a:pPr indent="0" marL="0">
+            <a:pPr marL="0" indent="0">
               <a:buNone/>
             </a:pPr>
             <a:r>
@@ -4430,11 +4094,11 @@
           <a:bodyPr wrap="square" rtlCol="0" anchor="ctr"/>
           <a:lstStyle/>
           <a:p>
-            <a:pPr indent="0" marL="0">
-              <a:buNone/>
-            </a:pPr>
-            <a:r>
-              <a:rPr lang="en-US" sz="900" b="1" spc="400" kern="0" dirty="0">
+            <a:pPr marL="0" indent="0">
+              <a:buNone/>
+            </a:pPr>
+            <a:r>
+              <a:rPr lang="en-US" sz="900" b="1" kern="0" spc="400" dirty="0">
                 <a:solidFill>
                   <a:srgbClr val="A8D8B0"/>
                 </a:solidFill>
@@ -4469,7 +4133,7 @@
           <a:bodyPr wrap="square" rtlCol="0" anchor="ctr"/>
           <a:lstStyle/>
           <a:p>
-            <a:pPr indent="0" marL="0">
+            <a:pPr marL="0" indent="0">
               <a:buNone/>
             </a:pPr>
             <a:r>
@@ -4508,7 +4172,7 @@
           <a:bodyPr wrap="square" rtlCol="0" anchor="ctr"/>
           <a:lstStyle/>
           <a:p>
-            <a:pPr indent="0" marL="0">
+            <a:pPr marL="0" indent="0">
               <a:buNone/>
             </a:pPr>
             <a:r>
@@ -4547,7 +4211,7 @@
           <a:bodyPr wrap="square" rtlCol="0" anchor="ctr"/>
           <a:lstStyle/>
           <a:p>
-            <a:pPr indent="0" marL="0">
+            <a:pPr marL="0" indent="0">
               <a:buNone/>
             </a:pPr>
             <a:r>
@@ -4581,6 +4245,7 @@
         <a:solidFill>
           <a:srgbClr val="F5FBF7"/>
         </a:solidFill>
+        <a:effectLst/>
       </p:bgPr>
     </p:bg>
     <p:spTree>
@@ -4643,7 +4308,7 @@
           <a:bodyPr wrap="square" rtlCol="0" anchor="ctr"/>
           <a:lstStyle/>
           <a:p>
-            <a:pPr indent="0" marL="0">
+            <a:pPr marL="0" indent="0">
               <a:buNone/>
             </a:pPr>
             <a:r>
@@ -4682,7 +4347,7 @@
           <a:bodyPr wrap="square" rtlCol="0" anchor="ctr"/>
           <a:lstStyle/>
           <a:p>
-            <a:pPr indent="0" marL="0">
+            <a:pPr marL="0" indent="0">
               <a:buNone/>
             </a:pPr>
             <a:r>
@@ -4830,7 +4495,7 @@
             <a:prstDash val="solid"/>
           </a:ln>
           <a:effectLst>
-            <a:outerShdw sx="100000" sy="100000" kx="0" ky="0" algn="bl" rotWithShape="0" blurRad="101600" dist="38100" dir="8100000">
+            <a:outerShdw blurRad="101600" dist="38100" dir="8100000" algn="bl" rotWithShape="0">
               <a:srgbClr val="000000">
                 <a:alpha val="25000"/>
               </a:srgbClr>
@@ -4859,7 +4524,7 @@
           <a:bodyPr wrap="square" rtlCol="0" anchor="ctr"/>
           <a:lstStyle/>
           <a:p>
-            <a:pPr indent="0" marL="0">
+            <a:pPr marL="0" indent="0">
               <a:buNone/>
             </a:pPr>
             <a:r>
@@ -4876,7 +4541,7 @@
             <a:endParaRPr lang="en-US" sz="950" dirty="0"/>
           </a:p>
           <a:p>
-            <a:pPr indent="0" marL="0">
+            <a:pPr marL="0" indent="0">
               <a:buNone/>
             </a:pPr>
             <a:r>
@@ -4893,7 +4558,7 @@
             <a:endParaRPr lang="en-US" sz="950" dirty="0"/>
           </a:p>
           <a:p>
-            <a:pPr indent="0" marL="0">
+            <a:pPr marL="0" indent="0">
               <a:buNone/>
             </a:pPr>
             <a:r>
@@ -4910,7 +4575,7 @@
             <a:endParaRPr lang="en-US" sz="950" dirty="0"/>
           </a:p>
           <a:p>
-            <a:pPr indent="0" marL="0">
+            <a:pPr marL="0" indent="0">
               <a:buNone/>
             </a:pPr>
             <a:r>
@@ -4927,13 +4592,13 @@
             <a:endParaRPr lang="en-US" sz="950" dirty="0"/>
           </a:p>
           <a:p>
-            <a:pPr indent="0" marL="0">
+            <a:pPr marL="0" indent="0">
               <a:buNone/>
             </a:pPr>
             <a:endParaRPr lang="en-US" sz="950" dirty="0"/>
           </a:p>
           <a:p>
-            <a:pPr indent="0" marL="0">
+            <a:pPr marL="0" indent="0">
               <a:buNone/>
             </a:pPr>
             <a:r>
@@ -4950,7 +4615,7 @@
             <a:endParaRPr lang="en-US" sz="950" dirty="0"/>
           </a:p>
           <a:p>
-            <a:pPr indent="0" marL="0">
+            <a:pPr marL="0" indent="0">
               <a:buNone/>
             </a:pPr>
             <a:r>
@@ -4967,7 +4632,7 @@
             <a:endParaRPr lang="en-US" sz="950" dirty="0"/>
           </a:p>
           <a:p>
-            <a:pPr indent="0" marL="0">
+            <a:pPr marL="0" indent="0">
               <a:buNone/>
             </a:pPr>
             <a:r>
@@ -4984,7 +4649,7 @@
             <a:endParaRPr lang="en-US" sz="950" dirty="0"/>
           </a:p>
           <a:p>
-            <a:pPr indent="0" marL="0">
+            <a:pPr marL="0" indent="0">
               <a:buNone/>
             </a:pPr>
             <a:r>
@@ -5001,7 +4666,7 @@
             <a:endParaRPr lang="en-US" sz="950" dirty="0"/>
           </a:p>
           <a:p>
-            <a:pPr indent="0" marL="0">
+            <a:pPr marL="0" indent="0">
               <a:buNone/>
             </a:pPr>
             <a:r>
@@ -5018,7 +4683,7 @@
             <a:endParaRPr lang="en-US" sz="950" dirty="0"/>
           </a:p>
           <a:p>
-            <a:pPr indent="0" marL="0">
+            <a:pPr marL="0" indent="0">
               <a:buNone/>
             </a:pPr>
             <a:r>
@@ -5035,7 +4700,7 @@
             <a:endParaRPr lang="en-US" sz="950" dirty="0"/>
           </a:p>
           <a:p>
-            <a:pPr indent="0" marL="0">
+            <a:pPr marL="0" indent="0">
               <a:buNone/>
             </a:pPr>
             <a:r>
@@ -5052,7 +4717,7 @@
             <a:endParaRPr lang="en-US" sz="950" dirty="0"/>
           </a:p>
           <a:p>
-            <a:pPr indent="0" marL="0">
+            <a:pPr marL="0" indent="0">
               <a:buNone/>
             </a:pPr>
             <a:r>
@@ -5069,7 +4734,7 @@
             <a:endParaRPr lang="en-US" sz="950" dirty="0"/>
           </a:p>
           <a:p>
-            <a:pPr indent="0" marL="0">
+            <a:pPr marL="0" indent="0">
               <a:buNone/>
             </a:pPr>
             <a:r>
@@ -5103,6 +4768,7 @@
         <a:solidFill>
           <a:srgbClr val="1A3A2A"/>
         </a:solidFill>
+        <a:effectLst/>
       </p:bgPr>
     </p:bg>
     <p:spTree>
@@ -5140,7 +4806,7 @@
           <a:bodyPr wrap="square" rtlCol="0" anchor="ctr"/>
           <a:lstStyle/>
           <a:p>
-            <a:pPr indent="0" marL="0">
+            <a:pPr marL="0" indent="0">
               <a:buNone/>
             </a:pPr>
             <a:r>
@@ -5179,11 +4845,11 @@
           <a:bodyPr wrap="square" rtlCol="0" anchor="ctr"/>
           <a:lstStyle/>
           <a:p>
-            <a:pPr indent="0" marL="0">
-              <a:buNone/>
-            </a:pPr>
-            <a:r>
-              <a:rPr lang="en-US" sz="900" b="1" spc="400" kern="0" dirty="0">
+            <a:pPr marL="0" indent="0">
+              <a:buNone/>
+            </a:pPr>
+            <a:r>
+              <a:rPr lang="en-US" sz="900" b="1" kern="0" spc="400" dirty="0">
                 <a:solidFill>
                   <a:srgbClr val="A8D8B0"/>
                 </a:solidFill>
@@ -5218,7 +4884,7 @@
           <a:bodyPr wrap="square" rtlCol="0" anchor="ctr"/>
           <a:lstStyle/>
           <a:p>
-            <a:pPr indent="0" marL="0">
+            <a:pPr marL="0" indent="0">
               <a:buNone/>
             </a:pPr>
             <a:r>
@@ -5257,7 +4923,7 @@
           <a:bodyPr wrap="square" rtlCol="0" anchor="ctr"/>
           <a:lstStyle/>
           <a:p>
-            <a:pPr indent="0" marL="0">
+            <a:pPr marL="0" indent="0">
               <a:buNone/>
             </a:pPr>
             <a:r>
@@ -5296,7 +4962,7 @@
           <a:bodyPr wrap="square" rtlCol="0" anchor="ctr"/>
           <a:lstStyle/>
           <a:p>
-            <a:pPr indent="0" marL="0">
+            <a:pPr marL="0" indent="0">
               <a:buNone/>
             </a:pPr>
             <a:r>
@@ -5330,6 +4996,7 @@
         <a:solidFill>
           <a:srgbClr val="F5FBF7"/>
         </a:solidFill>
+        <a:effectLst/>
       </p:bgPr>
     </p:bg>
     <p:spTree>
@@ -5392,7 +5059,7 @@
           <a:bodyPr wrap="square" rtlCol="0" anchor="ctr"/>
           <a:lstStyle/>
           <a:p>
-            <a:pPr indent="0" marL="0">
+            <a:pPr marL="0" indent="0">
               <a:buNone/>
             </a:pPr>
             <a:r>
@@ -5431,7 +5098,7 @@
           <a:bodyPr wrap="square" rtlCol="0" anchor="ctr"/>
           <a:lstStyle/>
           <a:p>
-            <a:pPr indent="0" marL="0">
+            <a:pPr marL="0" indent="0">
               <a:buNone/>
             </a:pPr>
             <a:r>
@@ -5579,7 +5246,7 @@
             <a:prstDash val="solid"/>
           </a:ln>
           <a:effectLst>
-            <a:outerShdw sx="100000" sy="100000" kx="0" ky="0" algn="bl" rotWithShape="0" blurRad="101600" dist="38100" dir="8100000">
+            <a:outerShdw blurRad="101600" dist="38100" dir="8100000" algn="bl" rotWithShape="0">
               <a:srgbClr val="000000">
                 <a:alpha val="25000"/>
               </a:srgbClr>
@@ -5608,7 +5275,7 @@
           <a:bodyPr wrap="square" rtlCol="0" anchor="ctr"/>
           <a:lstStyle/>
           <a:p>
-            <a:pPr indent="0" marL="0">
+            <a:pPr marL="0" indent="0">
               <a:buNone/>
             </a:pPr>
             <a:r>
@@ -5625,7 +5292,7 @@
             <a:endParaRPr lang="en-US" sz="950" dirty="0"/>
           </a:p>
           <a:p>
-            <a:pPr indent="0" marL="0">
+            <a:pPr marL="0" indent="0">
               <a:buNone/>
             </a:pPr>
             <a:r>
@@ -5642,7 +5309,7 @@
             <a:endParaRPr lang="en-US" sz="950" dirty="0"/>
           </a:p>
           <a:p>
-            <a:pPr indent="0" marL="0">
+            <a:pPr marL="0" indent="0">
               <a:buNone/>
             </a:pPr>
             <a:r>
@@ -5659,7 +5326,7 @@
             <a:endParaRPr lang="en-US" sz="950" dirty="0"/>
           </a:p>
           <a:p>
-            <a:pPr indent="0" marL="0">
+            <a:pPr marL="0" indent="0">
               <a:buNone/>
             </a:pPr>
             <a:r>
@@ -5676,13 +5343,13 @@
             <a:endParaRPr lang="en-US" sz="950" dirty="0"/>
           </a:p>
           <a:p>
-            <a:pPr indent="0" marL="0">
+            <a:pPr marL="0" indent="0">
               <a:buNone/>
             </a:pPr>
             <a:endParaRPr lang="en-US" sz="950" dirty="0"/>
           </a:p>
           <a:p>
-            <a:pPr indent="0" marL="0">
+            <a:pPr marL="0" indent="0">
               <a:buNone/>
             </a:pPr>
             <a:r>
@@ -5699,7 +5366,7 @@
             <a:endParaRPr lang="en-US" sz="950" dirty="0"/>
           </a:p>
           <a:p>
-            <a:pPr indent="0" marL="0">
+            <a:pPr marL="0" indent="0">
               <a:buNone/>
             </a:pPr>
             <a:r>
@@ -5716,7 +5383,7 @@
             <a:endParaRPr lang="en-US" sz="950" dirty="0"/>
           </a:p>
           <a:p>
-            <a:pPr indent="0" marL="0">
+            <a:pPr marL="0" indent="0">
               <a:buNone/>
             </a:pPr>
             <a:r>
@@ -5733,7 +5400,7 @@
             <a:endParaRPr lang="en-US" sz="950" dirty="0"/>
           </a:p>
           <a:p>
-            <a:pPr indent="0" marL="0">
+            <a:pPr marL="0" indent="0">
               <a:buNone/>
             </a:pPr>
             <a:r>
@@ -5750,7 +5417,7 @@
             <a:endParaRPr lang="en-US" sz="950" dirty="0"/>
           </a:p>
           <a:p>
-            <a:pPr indent="0" marL="0">
+            <a:pPr marL="0" indent="0">
               <a:buNone/>
             </a:pPr>
             <a:r>
@@ -5814,7 +5481,7 @@
           <a:bodyPr wrap="square" rtlCol="0" anchor="ctr"/>
           <a:lstStyle/>
           <a:p>
-            <a:pPr indent="0" marL="0">
+            <a:pPr marL="0" indent="0">
               <a:buNone/>
             </a:pPr>
             <a:r>
@@ -5848,6 +5515,7 @@
         <a:solidFill>
           <a:srgbClr val="F5FBF7"/>
         </a:solidFill>
+        <a:effectLst/>
       </p:bgPr>
     </p:bg>
     <p:spTree>
@@ -5910,7 +5578,7 @@
           <a:bodyPr wrap="square" rtlCol="0" anchor="ctr"/>
           <a:lstStyle/>
           <a:p>
-            <a:pPr indent="0" marL="0">
+            <a:pPr marL="0" indent="0">
               <a:buNone/>
             </a:pPr>
             <a:r>
@@ -5949,7 +5617,7 @@
           <a:bodyPr wrap="square" rtlCol="0" anchor="ctr"/>
           <a:lstStyle/>
           <a:p>
-            <a:pPr indent="0" marL="0">
+            <a:pPr marL="0" indent="0">
               <a:buNone/>
             </a:pPr>
             <a:r>
@@ -6097,7 +5765,7 @@
             <a:prstDash val="solid"/>
           </a:ln>
           <a:effectLst>
-            <a:outerShdw sx="100000" sy="100000" kx="0" ky="0" algn="bl" rotWithShape="0" blurRad="101600" dist="38100" dir="8100000">
+            <a:outerShdw blurRad="101600" dist="38100" dir="8100000" algn="bl" rotWithShape="0">
               <a:srgbClr val="000000">
                 <a:alpha val="25000"/>
               </a:srgbClr>
@@ -6126,7 +5794,7 @@
           <a:bodyPr wrap="square" rtlCol="0" anchor="ctr"/>
           <a:lstStyle/>
           <a:p>
-            <a:pPr indent="0" marL="0">
+            <a:pPr marL="0" indent="0">
               <a:buNone/>
             </a:pPr>
             <a:r>
@@ -6143,7 +5811,7 @@
             <a:endParaRPr lang="en-US" sz="950" dirty="0"/>
           </a:p>
           <a:p>
-            <a:pPr indent="0" marL="0">
+            <a:pPr marL="0" indent="0">
               <a:buNone/>
             </a:pPr>
             <a:r>
@@ -6160,7 +5828,7 @@
             <a:endParaRPr lang="en-US" sz="950" dirty="0"/>
           </a:p>
           <a:p>
-            <a:pPr indent="0" marL="0">
+            <a:pPr marL="0" indent="0">
               <a:buNone/>
             </a:pPr>
             <a:r>
@@ -6177,7 +5845,7 @@
             <a:endParaRPr lang="en-US" sz="950" dirty="0"/>
           </a:p>
           <a:p>
-            <a:pPr indent="0" marL="0">
+            <a:pPr marL="0" indent="0">
               <a:buNone/>
             </a:pPr>
             <a:r>
@@ -6194,7 +5862,7 @@
             <a:endParaRPr lang="en-US" sz="950" dirty="0"/>
           </a:p>
           <a:p>
-            <a:pPr indent="0" marL="0">
+            <a:pPr marL="0" indent="0">
               <a:buNone/>
             </a:pPr>
             <a:r>
@@ -6211,13 +5879,13 @@
             <a:endParaRPr lang="en-US" sz="950" dirty="0"/>
           </a:p>
           <a:p>
-            <a:pPr indent="0" marL="0">
+            <a:pPr marL="0" indent="0">
               <a:buNone/>
             </a:pPr>
             <a:endParaRPr lang="en-US" sz="950" dirty="0"/>
           </a:p>
           <a:p>
-            <a:pPr indent="0" marL="0">
+            <a:pPr marL="0" indent="0">
               <a:buNone/>
             </a:pPr>
             <a:r>
@@ -6234,7 +5902,7 @@
             <a:endParaRPr lang="en-US" sz="950" dirty="0"/>
           </a:p>
           <a:p>
-            <a:pPr indent="0" marL="0">
+            <a:pPr marL="0" indent="0">
               <a:buNone/>
             </a:pPr>
             <a:r>
@@ -6251,7 +5919,7 @@
             <a:endParaRPr lang="en-US" sz="950" dirty="0"/>
           </a:p>
           <a:p>
-            <a:pPr indent="0" marL="0">
+            <a:pPr marL="0" indent="0">
               <a:buNone/>
             </a:pPr>
             <a:r>
@@ -6268,7 +5936,7 @@
             <a:endParaRPr lang="en-US" sz="950" dirty="0"/>
           </a:p>
           <a:p>
-            <a:pPr indent="0" marL="0">
+            <a:pPr marL="0" indent="0">
               <a:buNone/>
             </a:pPr>
             <a:r>
@@ -6285,7 +5953,7 @@
             <a:endParaRPr lang="en-US" sz="950" dirty="0"/>
           </a:p>
           <a:p>
-            <a:pPr indent="0" marL="0">
+            <a:pPr marL="0" indent="0">
               <a:buNone/>
             </a:pPr>
             <a:r>
@@ -6302,7 +5970,7 @@
             <a:endParaRPr lang="en-US" sz="950" dirty="0"/>
           </a:p>
           <a:p>
-            <a:pPr indent="0" marL="0">
+            <a:pPr marL="0" indent="0">
               <a:buNone/>
             </a:pPr>
             <a:r>
@@ -6366,7 +6034,7 @@
           <a:bodyPr wrap="square" rtlCol="0" anchor="ctr"/>
           <a:lstStyle/>
           <a:p>
-            <a:pPr indent="0" marL="0">
+            <a:pPr marL="0" indent="0">
               <a:buNone/>
             </a:pPr>
             <a:r>
@@ -6400,6 +6068,7 @@
         <a:solidFill>
           <a:srgbClr val="1A3A2A"/>
         </a:solidFill>
+        <a:effectLst/>
       </p:bgPr>
     </p:bg>
     <p:spTree>
@@ -6437,7 +6106,7 @@
           <a:bodyPr wrap="square" rtlCol="0" anchor="ctr"/>
           <a:lstStyle/>
           <a:p>
-            <a:pPr indent="0" marL="0">
+            <a:pPr marL="0" indent="0">
               <a:buNone/>
             </a:pPr>
             <a:r>
@@ -6476,11 +6145,11 @@
           <a:bodyPr wrap="square" rtlCol="0" anchor="ctr"/>
           <a:lstStyle/>
           <a:p>
-            <a:pPr indent="0" marL="0">
-              <a:buNone/>
-            </a:pPr>
-            <a:r>
-              <a:rPr lang="en-US" sz="900" b="1" spc="400" kern="0" dirty="0">
+            <a:pPr marL="0" indent="0">
+              <a:buNone/>
+            </a:pPr>
+            <a:r>
+              <a:rPr lang="en-US" sz="900" b="1" kern="0" spc="400" dirty="0">
                 <a:solidFill>
                   <a:srgbClr val="A8D8B0"/>
                 </a:solidFill>
@@ -6515,7 +6184,7 @@
           <a:bodyPr wrap="square" rtlCol="0" anchor="ctr"/>
           <a:lstStyle/>
           <a:p>
-            <a:pPr indent="0" marL="0">
+            <a:pPr marL="0" indent="0">
               <a:buNone/>
             </a:pPr>
             <a:r>
@@ -6554,7 +6223,7 @@
           <a:bodyPr wrap="square" rtlCol="0" anchor="ctr"/>
           <a:lstStyle/>
           <a:p>
-            <a:pPr indent="0" marL="0">
+            <a:pPr marL="0" indent="0">
               <a:buNone/>
             </a:pPr>
             <a:r>
@@ -6593,7 +6262,7 @@
           <a:bodyPr wrap="square" rtlCol="0" anchor="ctr"/>
           <a:lstStyle/>
           <a:p>
-            <a:pPr indent="0" marL="0">
+            <a:pPr marL="0" indent="0">
               <a:buNone/>
             </a:pPr>
             <a:r>
@@ -6627,6 +6296,7 @@
         <a:solidFill>
           <a:srgbClr val="F5FBF7"/>
         </a:solidFill>
+        <a:effectLst/>
       </p:bgPr>
     </p:bg>
     <p:spTree>
@@ -6689,7 +6359,7 @@
           <a:bodyPr wrap="square" rtlCol="0" anchor="ctr"/>
           <a:lstStyle/>
           <a:p>
-            <a:pPr indent="0" marL="0">
+            <a:pPr marL="0" indent="0">
               <a:buNone/>
             </a:pPr>
             <a:r>
@@ -6728,7 +6398,7 @@
           <a:bodyPr wrap="square" rtlCol="0" anchor="ctr"/>
           <a:lstStyle/>
           <a:p>
-            <a:pPr indent="0" marL="0">
+            <a:pPr marL="0" indent="0">
               <a:buNone/>
             </a:pPr>
             <a:r>
@@ -6876,7 +6546,7 @@
             <a:prstDash val="solid"/>
           </a:ln>
           <a:effectLst>
-            <a:outerShdw sx="100000" sy="100000" kx="0" ky="0" algn="bl" rotWithShape="0" blurRad="101600" dist="38100" dir="8100000">
+            <a:outerShdw blurRad="101600" dist="38100" dir="8100000" algn="bl" rotWithShape="0">
               <a:srgbClr val="000000">
                 <a:alpha val="25000"/>
               </a:srgbClr>
@@ -6905,7 +6575,7 @@
           <a:bodyPr wrap="square" rtlCol="0" anchor="ctr"/>
           <a:lstStyle/>
           <a:p>
-            <a:pPr indent="0" marL="0">
+            <a:pPr marL="0" indent="0">
               <a:buNone/>
             </a:pPr>
             <a:r>
@@ -6922,7 +6592,7 @@
             <a:endParaRPr lang="en-US" sz="950" dirty="0"/>
           </a:p>
           <a:p>
-            <a:pPr indent="0" marL="0">
+            <a:pPr marL="0" indent="0">
               <a:buNone/>
             </a:pPr>
             <a:r>
@@ -6939,7 +6609,7 @@
             <a:endParaRPr lang="en-US" sz="950" dirty="0"/>
           </a:p>
           <a:p>
-            <a:pPr indent="0" marL="0">
+            <a:pPr marL="0" indent="0">
               <a:buNone/>
             </a:pPr>
             <a:r>
@@ -6956,13 +6626,13 @@
             <a:endParaRPr lang="en-US" sz="950" dirty="0"/>
           </a:p>
           <a:p>
-            <a:pPr indent="0" marL="0">
+            <a:pPr marL="0" indent="0">
               <a:buNone/>
             </a:pPr>
             <a:endParaRPr lang="en-US" sz="950" dirty="0"/>
           </a:p>
           <a:p>
-            <a:pPr indent="0" marL="0">
+            <a:pPr marL="0" indent="0">
               <a:buNone/>
             </a:pPr>
             <a:r>
@@ -6979,7 +6649,7 @@
             <a:endParaRPr lang="en-US" sz="950" dirty="0"/>
           </a:p>
           <a:p>
-            <a:pPr indent="0" marL="0">
+            <a:pPr marL="0" indent="0">
               <a:buNone/>
             </a:pPr>
             <a:r>
@@ -6996,7 +6666,7 @@
             <a:endParaRPr lang="en-US" sz="950" dirty="0"/>
           </a:p>
           <a:p>
-            <a:pPr indent="0" marL="0">
+            <a:pPr marL="0" indent="0">
               <a:buNone/>
             </a:pPr>
             <a:r>
@@ -7013,7 +6683,7 @@
             <a:endParaRPr lang="en-US" sz="950" dirty="0"/>
           </a:p>
           <a:p>
-            <a:pPr indent="0" marL="0">
+            <a:pPr marL="0" indent="0">
               <a:buNone/>
             </a:pPr>
             <a:r>
@@ -7030,13 +6700,13 @@
             <a:endParaRPr lang="en-US" sz="950" dirty="0"/>
           </a:p>
           <a:p>
-            <a:pPr indent="0" marL="0">
+            <a:pPr marL="0" indent="0">
               <a:buNone/>
             </a:pPr>
             <a:endParaRPr lang="en-US" sz="950" dirty="0"/>
           </a:p>
           <a:p>
-            <a:pPr indent="0" marL="0">
+            <a:pPr marL="0" indent="0">
               <a:buNone/>
             </a:pPr>
             <a:r>
@@ -7053,7 +6723,7 @@
             <a:endParaRPr lang="en-US" sz="950" dirty="0"/>
           </a:p>
           <a:p>
-            <a:pPr indent="0" marL="0">
+            <a:pPr marL="0" indent="0">
               <a:buNone/>
             </a:pPr>
             <a:r>
@@ -7070,7 +6740,7 @@
             <a:endParaRPr lang="en-US" sz="950" dirty="0"/>
           </a:p>
           <a:p>
-            <a:pPr indent="0" marL="0">
+            <a:pPr marL="0" indent="0">
               <a:buNone/>
             </a:pPr>
             <a:r>
@@ -7134,7 +6804,7 @@
           <a:bodyPr wrap="square" rtlCol="0" anchor="ctr"/>
           <a:lstStyle/>
           <a:p>
-            <a:pPr indent="0" marL="0">
+            <a:pPr marL="0" indent="0">
               <a:buNone/>
             </a:pPr>
             <a:r>
@@ -7168,6 +6838,7 @@
         <a:solidFill>
           <a:srgbClr val="F5FBF7"/>
         </a:solidFill>
+        <a:effectLst/>
       </p:bgPr>
     </p:bg>
     <p:spTree>
@@ -7230,7 +6901,7 @@
           <a:bodyPr wrap="square" rtlCol="0" anchor="ctr"/>
           <a:lstStyle/>
           <a:p>
-            <a:pPr indent="0" marL="0">
+            <a:pPr marL="0" indent="0">
               <a:buNone/>
             </a:pPr>
             <a:r>
@@ -7269,7 +6940,7 @@
           <a:bodyPr wrap="square" rtlCol="0" anchor="ctr"/>
           <a:lstStyle/>
           <a:p>
-            <a:pPr indent="0" marL="0">
+            <a:pPr marL="0" indent="0">
               <a:buNone/>
             </a:pPr>
             <a:r>
@@ -7417,7 +7088,7 @@
             <a:prstDash val="solid"/>
           </a:ln>
           <a:effectLst>
-            <a:outerShdw sx="100000" sy="100000" kx="0" ky="0" algn="bl" rotWithShape="0" blurRad="101600" dist="38100" dir="8100000">
+            <a:outerShdw blurRad="101600" dist="38100" dir="8100000" algn="bl" rotWithShape="0">
               <a:srgbClr val="000000">
                 <a:alpha val="25000"/>
               </a:srgbClr>
@@ -7446,7 +7117,7 @@
           <a:bodyPr wrap="square" rtlCol="0" anchor="ctr"/>
           <a:lstStyle/>
           <a:p>
-            <a:pPr indent="0" marL="0">
+            <a:pPr marL="0" indent="0">
               <a:buNone/>
             </a:pPr>
             <a:r>
@@ -7463,7 +7134,7 @@
             <a:endParaRPr lang="en-US" sz="950" dirty="0"/>
           </a:p>
           <a:p>
-            <a:pPr indent="0" marL="0">
+            <a:pPr marL="0" indent="0">
               <a:buNone/>
             </a:pPr>
             <a:r>
@@ -7480,7 +7151,7 @@
             <a:endParaRPr lang="en-US" sz="950" dirty="0"/>
           </a:p>
           <a:p>
-            <a:pPr indent="0" marL="0">
+            <a:pPr marL="0" indent="0">
               <a:buNone/>
             </a:pPr>
             <a:r>
@@ -7497,7 +7168,7 @@
             <a:endParaRPr lang="en-US" sz="950" dirty="0"/>
           </a:p>
           <a:p>
-            <a:pPr indent="0" marL="0">
+            <a:pPr marL="0" indent="0">
               <a:buNone/>
             </a:pPr>
             <a:r>
@@ -7514,7 +7185,7 @@
             <a:endParaRPr lang="en-US" sz="950" dirty="0"/>
           </a:p>
           <a:p>
-            <a:pPr indent="0" marL="0">
+            <a:pPr marL="0" indent="0">
               <a:buNone/>
             </a:pPr>
             <a:r>
@@ -7531,13 +7202,13 @@
             <a:endParaRPr lang="en-US" sz="950" dirty="0"/>
           </a:p>
           <a:p>
-            <a:pPr indent="0" marL="0">
+            <a:pPr marL="0" indent="0">
               <a:buNone/>
             </a:pPr>
             <a:endParaRPr lang="en-US" sz="950" dirty="0"/>
           </a:p>
           <a:p>
-            <a:pPr indent="0" marL="0">
+            <a:pPr marL="0" indent="0">
               <a:buNone/>
             </a:pPr>
             <a:r>
@@ -7554,7 +7225,7 @@
             <a:endParaRPr lang="en-US" sz="950" dirty="0"/>
           </a:p>
           <a:p>
-            <a:pPr indent="0" marL="0">
+            <a:pPr marL="0" indent="0">
               <a:buNone/>
             </a:pPr>
             <a:r>
@@ -7571,7 +7242,7 @@
             <a:endParaRPr lang="en-US" sz="950" dirty="0"/>
           </a:p>
           <a:p>
-            <a:pPr indent="0" marL="0">
+            <a:pPr marL="0" indent="0">
               <a:buNone/>
             </a:pPr>
             <a:r>
@@ -7588,7 +7259,7 @@
             <a:endParaRPr lang="en-US" sz="950" dirty="0"/>
           </a:p>
           <a:p>
-            <a:pPr indent="0" marL="0">
+            <a:pPr marL="0" indent="0">
               <a:buNone/>
             </a:pPr>
             <a:r>
@@ -7605,7 +7276,7 @@
             <a:endParaRPr lang="en-US" sz="950" dirty="0"/>
           </a:p>
           <a:p>
-            <a:pPr indent="0" marL="0">
+            <a:pPr marL="0" indent="0">
               <a:buNone/>
             </a:pPr>
             <a:r>
@@ -7622,7 +7293,7 @@
             <a:endParaRPr lang="en-US" sz="950" dirty="0"/>
           </a:p>
           <a:p>
-            <a:pPr indent="0" marL="0">
+            <a:pPr marL="0" indent="0">
               <a:buNone/>
             </a:pPr>
             <a:r>
@@ -7686,7 +7357,7 @@
           <a:bodyPr wrap="square" rtlCol="0" anchor="ctr"/>
           <a:lstStyle/>
           <a:p>
-            <a:pPr indent="0" marL="0">
+            <a:pPr marL="0" indent="0">
               <a:buNone/>
             </a:pPr>
             <a:r>
@@ -7720,6 +7391,7 @@
         <a:solidFill>
           <a:srgbClr val="F5FBF7"/>
         </a:solidFill>
+        <a:effectLst/>
       </p:bgPr>
     </p:bg>
     <p:spTree>
@@ -7782,7 +7454,7 @@
           <a:bodyPr wrap="square" rtlCol="0" anchor="ctr"/>
           <a:lstStyle/>
           <a:p>
-            <a:pPr indent="0" marL="0">
+            <a:pPr marL="0" indent="0">
               <a:buNone/>
             </a:pPr>
             <a:r>
@@ -7821,7 +7493,7 @@
           <a:bodyPr wrap="square" rtlCol="0" anchor="ctr"/>
           <a:lstStyle/>
           <a:p>
-            <a:pPr indent="0" marL="0">
+            <a:pPr marL="0" indent="0">
               <a:buNone/>
             </a:pPr>
             <a:r>
@@ -7969,7 +7641,7 @@
             <a:prstDash val="solid"/>
           </a:ln>
           <a:effectLst>
-            <a:outerShdw sx="100000" sy="100000" kx="0" ky="0" algn="bl" rotWithShape="0" blurRad="101600" dist="38100" dir="8100000">
+            <a:outerShdw blurRad="101600" dist="38100" dir="8100000" algn="bl" rotWithShape="0">
               <a:srgbClr val="000000">
                 <a:alpha val="25000"/>
               </a:srgbClr>
@@ -7998,7 +7670,7 @@
           <a:bodyPr wrap="square" rtlCol="0" anchor="ctr"/>
           <a:lstStyle/>
           <a:p>
-            <a:pPr indent="0" marL="0">
+            <a:pPr marL="0" indent="0">
               <a:buNone/>
             </a:pPr>
             <a:r>
@@ -8015,7 +7687,7 @@
             <a:endParaRPr lang="en-US" sz="950" dirty="0"/>
           </a:p>
           <a:p>
-            <a:pPr indent="0" marL="0">
+            <a:pPr marL="0" indent="0">
               <a:buNone/>
             </a:pPr>
             <a:r>
@@ -8032,7 +7704,7 @@
             <a:endParaRPr lang="en-US" sz="950" dirty="0"/>
           </a:p>
           <a:p>
-            <a:pPr indent="0" marL="0">
+            <a:pPr marL="0" indent="0">
               <a:buNone/>
             </a:pPr>
             <a:r>
@@ -8049,13 +7721,13 @@
             <a:endParaRPr lang="en-US" sz="950" dirty="0"/>
           </a:p>
           <a:p>
-            <a:pPr indent="0" marL="0">
+            <a:pPr marL="0" indent="0">
               <a:buNone/>
             </a:pPr>
             <a:endParaRPr lang="en-US" sz="950" dirty="0"/>
           </a:p>
           <a:p>
-            <a:pPr indent="0" marL="0">
+            <a:pPr marL="0" indent="0">
               <a:buNone/>
             </a:pPr>
             <a:r>
@@ -8072,7 +7744,7 @@
             <a:endParaRPr lang="en-US" sz="950" dirty="0"/>
           </a:p>
           <a:p>
-            <a:pPr indent="0" marL="0">
+            <a:pPr marL="0" indent="0">
               <a:buNone/>
             </a:pPr>
             <a:r>
@@ -8089,7 +7761,7 @@
             <a:endParaRPr lang="en-US" sz="950" dirty="0"/>
           </a:p>
           <a:p>
-            <a:pPr indent="0" marL="0">
+            <a:pPr marL="0" indent="0">
               <a:buNone/>
             </a:pPr>
             <a:r>
@@ -8106,7 +7778,7 @@
             <a:endParaRPr lang="en-US" sz="950" dirty="0"/>
           </a:p>
           <a:p>
-            <a:pPr indent="0" marL="0">
+            <a:pPr marL="0" indent="0">
               <a:buNone/>
             </a:pPr>
             <a:r>
@@ -8123,13 +7795,13 @@
             <a:endParaRPr lang="en-US" sz="950" dirty="0"/>
           </a:p>
           <a:p>
-            <a:pPr indent="0" marL="0">
+            <a:pPr marL="0" indent="0">
               <a:buNone/>
             </a:pPr>
             <a:endParaRPr lang="en-US" sz="950" dirty="0"/>
           </a:p>
           <a:p>
-            <a:pPr indent="0" marL="0">
+            <a:pPr marL="0" indent="0">
               <a:buNone/>
             </a:pPr>
             <a:r>
@@ -8146,7 +7818,7 @@
             <a:endParaRPr lang="en-US" sz="950" dirty="0"/>
           </a:p>
           <a:p>
-            <a:pPr indent="0" marL="0">
+            <a:pPr marL="0" indent="0">
               <a:buNone/>
             </a:pPr>
             <a:r>
@@ -8163,7 +7835,7 @@
             <a:endParaRPr lang="en-US" sz="950" dirty="0"/>
           </a:p>
           <a:p>
-            <a:pPr indent="0" marL="0">
+            <a:pPr marL="0" indent="0">
               <a:buNone/>
             </a:pPr>
             <a:r>
@@ -8180,7 +7852,7 @@
             <a:endParaRPr lang="en-US" sz="950" dirty="0"/>
           </a:p>
           <a:p>
-            <a:pPr indent="0" marL="0">
+            <a:pPr marL="0" indent="0">
               <a:buNone/>
             </a:pPr>
             <a:r>
@@ -8197,7 +7869,7 @@
             <a:endParaRPr lang="en-US" sz="950" dirty="0"/>
           </a:p>
           <a:p>
-            <a:pPr indent="0" marL="0">
+            <a:pPr marL="0" indent="0">
               <a:buNone/>
             </a:pPr>
             <a:r>
@@ -8214,7 +7886,7 @@
             <a:endParaRPr lang="en-US" sz="950" dirty="0"/>
           </a:p>
           <a:p>
-            <a:pPr indent="0" marL="0">
+            <a:pPr marL="0" indent="0">
               <a:buNone/>
             </a:pPr>
             <a:r>
@@ -8231,7 +7903,7 @@
             <a:endParaRPr lang="en-US" sz="950" dirty="0"/>
           </a:p>
           <a:p>
-            <a:pPr indent="0" marL="0">
+            <a:pPr marL="0" indent="0">
               <a:buNone/>
             </a:pPr>
             <a:r>
@@ -8265,6 +7937,7 @@
         <a:solidFill>
           <a:srgbClr val="1A3A2A"/>
         </a:solidFill>
+        <a:effectLst/>
       </p:bgPr>
     </p:bg>
     <p:spTree>
@@ -8302,7 +7975,7 @@
           <a:bodyPr wrap="square" rtlCol="0" anchor="ctr"/>
           <a:lstStyle/>
           <a:p>
-            <a:pPr indent="0" marL="0">
+            <a:pPr marL="0" indent="0">
               <a:buNone/>
             </a:pPr>
             <a:r>
@@ -8341,11 +8014,11 @@
           <a:bodyPr wrap="square" rtlCol="0" anchor="ctr"/>
           <a:lstStyle/>
           <a:p>
-            <a:pPr indent="0" marL="0">
-              <a:buNone/>
-            </a:pPr>
-            <a:r>
-              <a:rPr lang="en-US" sz="900" b="1" spc="400" kern="0" dirty="0">
+            <a:pPr marL="0" indent="0">
+              <a:buNone/>
+            </a:pPr>
+            <a:r>
+              <a:rPr lang="en-US" sz="900" b="1" kern="0" spc="400" dirty="0">
                 <a:solidFill>
                   <a:srgbClr val="A8D8B0"/>
                 </a:solidFill>
@@ -8380,7 +8053,7 @@
           <a:bodyPr wrap="square" rtlCol="0" anchor="ctr"/>
           <a:lstStyle/>
           <a:p>
-            <a:pPr indent="0" marL="0">
+            <a:pPr marL="0" indent="0">
               <a:buNone/>
             </a:pPr>
             <a:r>
@@ -8419,7 +8092,7 @@
           <a:bodyPr wrap="square" rtlCol="0" anchor="ctr"/>
           <a:lstStyle/>
           <a:p>
-            <a:pPr indent="0" marL="0">
+            <a:pPr marL="0" indent="0">
               <a:buNone/>
             </a:pPr>
             <a:r>
@@ -8458,7 +8131,7 @@
           <a:bodyPr wrap="square" rtlCol="0" anchor="ctr"/>
           <a:lstStyle/>
           <a:p>
-            <a:pPr indent="0" marL="0">
+            <a:pPr marL="0" indent="0">
               <a:buNone/>
             </a:pPr>
             <a:r>
@@ -8492,6 +8165,7 @@
         <a:solidFill>
           <a:srgbClr val="F0FAF4"/>
         </a:solidFill>
+        <a:effectLst/>
       </p:bgPr>
     </p:bg>
     <p:spTree>
@@ -8529,7 +8203,7 @@
           <a:bodyPr wrap="square" rtlCol="0" anchor="ctr"/>
           <a:lstStyle/>
           <a:p>
-            <a:pPr indent="0" marL="0">
+            <a:pPr marL="0" indent="0">
               <a:buNone/>
             </a:pPr>
             <a:r>
@@ -8593,7 +8267,7 @@
           <a:bodyPr wrap="square" rtlCol="0" anchor="ctr"/>
           <a:lstStyle/>
           <a:p>
-            <a:pPr algn="ctr" indent="0" marL="0">
+            <a:pPr marL="0" indent="0" algn="ctr">
               <a:buNone/>
             </a:pPr>
             <a:r>
@@ -8632,7 +8306,7 @@
           <a:bodyPr wrap="square" rtlCol="0" anchor="ctr"/>
           <a:lstStyle/>
           <a:p>
-            <a:pPr indent="0" marL="0">
+            <a:pPr marL="0" indent="0">
               <a:buNone/>
             </a:pPr>
             <a:r>
@@ -8671,7 +8345,7 @@
           <a:bodyPr wrap="square" rtlCol="0" anchor="ctr"/>
           <a:lstStyle/>
           <a:p>
-            <a:pPr indent="0" marL="0">
+            <a:pPr marL="0" indent="0">
               <a:buNone/>
             </a:pPr>
             <a:r>
@@ -8735,7 +8409,7 @@
           <a:bodyPr wrap="square" rtlCol="0" anchor="ctr"/>
           <a:lstStyle/>
           <a:p>
-            <a:pPr algn="ctr" indent="0" marL="0">
+            <a:pPr marL="0" indent="0" algn="ctr">
               <a:buNone/>
             </a:pPr>
             <a:r>
@@ -8774,7 +8448,7 @@
           <a:bodyPr wrap="square" rtlCol="0" anchor="ctr"/>
           <a:lstStyle/>
           <a:p>
-            <a:pPr indent="0" marL="0">
+            <a:pPr marL="0" indent="0">
               <a:buNone/>
             </a:pPr>
             <a:r>
@@ -8813,7 +8487,7 @@
           <a:bodyPr wrap="square" rtlCol="0" anchor="ctr"/>
           <a:lstStyle/>
           <a:p>
-            <a:pPr indent="0" marL="0">
+            <a:pPr marL="0" indent="0">
               <a:buNone/>
             </a:pPr>
             <a:r>
@@ -8877,7 +8551,7 @@
           <a:bodyPr wrap="square" rtlCol="0" anchor="ctr"/>
           <a:lstStyle/>
           <a:p>
-            <a:pPr algn="ctr" indent="0" marL="0">
+            <a:pPr marL="0" indent="0" algn="ctr">
               <a:buNone/>
             </a:pPr>
             <a:r>
@@ -8916,7 +8590,7 @@
           <a:bodyPr wrap="square" rtlCol="0" anchor="ctr"/>
           <a:lstStyle/>
           <a:p>
-            <a:pPr indent="0" marL="0">
+            <a:pPr marL="0" indent="0">
               <a:buNone/>
             </a:pPr>
             <a:r>
@@ -8955,7 +8629,7 @@
           <a:bodyPr wrap="square" rtlCol="0" anchor="ctr"/>
           <a:lstStyle/>
           <a:p>
-            <a:pPr indent="0" marL="0">
+            <a:pPr marL="0" indent="0">
               <a:buNone/>
             </a:pPr>
             <a:r>
@@ -9019,7 +8693,7 @@
           <a:bodyPr wrap="square" rtlCol="0" anchor="ctr"/>
           <a:lstStyle/>
           <a:p>
-            <a:pPr algn="ctr" indent="0" marL="0">
+            <a:pPr marL="0" indent="0" algn="ctr">
               <a:buNone/>
             </a:pPr>
             <a:r>
@@ -9058,7 +8732,7 @@
           <a:bodyPr wrap="square" rtlCol="0" anchor="ctr"/>
           <a:lstStyle/>
           <a:p>
-            <a:pPr indent="0" marL="0">
+            <a:pPr marL="0" indent="0">
               <a:buNone/>
             </a:pPr>
             <a:r>
@@ -9097,7 +8771,7 @@
           <a:bodyPr wrap="square" rtlCol="0" anchor="ctr"/>
           <a:lstStyle/>
           <a:p>
-            <a:pPr indent="0" marL="0">
+            <a:pPr marL="0" indent="0">
               <a:buNone/>
             </a:pPr>
             <a:r>
@@ -9161,7 +8835,7 @@
           <a:bodyPr wrap="square" rtlCol="0" anchor="ctr"/>
           <a:lstStyle/>
           <a:p>
-            <a:pPr algn="ctr" indent="0" marL="0">
+            <a:pPr marL="0" indent="0" algn="ctr">
               <a:buNone/>
             </a:pPr>
             <a:r>
@@ -9200,7 +8874,7 @@
           <a:bodyPr wrap="square" rtlCol="0" anchor="ctr"/>
           <a:lstStyle/>
           <a:p>
-            <a:pPr indent="0" marL="0">
+            <a:pPr marL="0" indent="0">
               <a:buNone/>
             </a:pPr>
             <a:r>
@@ -9239,7 +8913,7 @@
           <a:bodyPr wrap="square" rtlCol="0" anchor="ctr"/>
           <a:lstStyle/>
           <a:p>
-            <a:pPr indent="0" marL="0">
+            <a:pPr marL="0" indent="0">
               <a:buNone/>
             </a:pPr>
             <a:r>
@@ -9303,7 +8977,7 @@
           <a:bodyPr wrap="square" rtlCol="0" anchor="ctr"/>
           <a:lstStyle/>
           <a:p>
-            <a:pPr algn="ctr" indent="0" marL="0">
+            <a:pPr marL="0" indent="0" algn="ctr">
               <a:buNone/>
             </a:pPr>
             <a:r>
@@ -9342,7 +9016,7 @@
           <a:bodyPr wrap="square" rtlCol="0" anchor="ctr"/>
           <a:lstStyle/>
           <a:p>
-            <a:pPr indent="0" marL="0">
+            <a:pPr marL="0" indent="0">
               <a:buNone/>
             </a:pPr>
             <a:r>
@@ -9381,7 +9055,7 @@
           <a:bodyPr wrap="square" rtlCol="0" anchor="ctr"/>
           <a:lstStyle/>
           <a:p>
-            <a:pPr indent="0" marL="0">
+            <a:pPr marL="0" indent="0">
               <a:buNone/>
             </a:pPr>
             <a:r>
@@ -9445,7 +9119,7 @@
           <a:bodyPr wrap="square" rtlCol="0" anchor="ctr"/>
           <a:lstStyle/>
           <a:p>
-            <a:pPr algn="ctr" indent="0" marL="0">
+            <a:pPr marL="0" indent="0" algn="ctr">
               <a:buNone/>
             </a:pPr>
             <a:r>
@@ -9484,7 +9158,7 @@
           <a:bodyPr wrap="square" rtlCol="0" anchor="ctr"/>
           <a:lstStyle/>
           <a:p>
-            <a:pPr indent="0" marL="0">
+            <a:pPr marL="0" indent="0">
               <a:buNone/>
             </a:pPr>
             <a:r>
@@ -9523,7 +9197,7 @@
           <a:bodyPr wrap="square" rtlCol="0" anchor="ctr"/>
           <a:lstStyle/>
           <a:p>
-            <a:pPr indent="0" marL="0">
+            <a:pPr marL="0" indent="0">
               <a:buNone/>
             </a:pPr>
             <a:r>
@@ -9562,7 +9236,7 @@
           <a:bodyPr wrap="square" rtlCol="0" anchor="ctr"/>
           <a:lstStyle/>
           <a:p>
-            <a:pPr indent="0" marL="0">
+            <a:pPr marL="0" indent="0">
               <a:buNone/>
             </a:pPr>
             <a:r>
@@ -9596,6 +9270,7 @@
         <a:solidFill>
           <a:srgbClr val="F5FBF7"/>
         </a:solidFill>
+        <a:effectLst/>
       </p:bgPr>
     </p:bg>
     <p:spTree>
@@ -9658,7 +9333,7 @@
           <a:bodyPr wrap="square" rtlCol="0" anchor="ctr"/>
           <a:lstStyle/>
           <a:p>
-            <a:pPr indent="0" marL="0">
+            <a:pPr marL="0" indent="0">
               <a:buNone/>
             </a:pPr>
             <a:r>
@@ -9722,7 +9397,7 @@
           <a:bodyPr wrap="square" rtlCol="0" anchor="ctr"/>
           <a:lstStyle/>
           <a:p>
-            <a:pPr indent="0" marL="0">
+            <a:pPr marL="0" indent="0">
               <a:buNone/>
             </a:pPr>
             <a:r>
@@ -9786,7 +9461,7 @@
           <a:bodyPr wrap="square" rtlCol="0" anchor="ctr"/>
           <a:lstStyle/>
           <a:p>
-            <a:pPr indent="0" marL="0">
+            <a:pPr marL="0" indent="0">
               <a:buNone/>
             </a:pPr>
             <a:r>
@@ -9850,7 +9525,7 @@
           <a:bodyPr wrap="square" rtlCol="0" anchor="ctr"/>
           <a:lstStyle/>
           <a:p>
-            <a:pPr indent="0" marL="0">
+            <a:pPr marL="0" indent="0">
               <a:buNone/>
             </a:pPr>
             <a:r>
@@ -9914,7 +9589,7 @@
           <a:bodyPr wrap="square" rtlCol="0" anchor="ctr"/>
           <a:lstStyle/>
           <a:p>
-            <a:pPr indent="0" marL="0">
+            <a:pPr marL="0" indent="0">
               <a:buNone/>
             </a:pPr>
             <a:r>
@@ -9978,7 +9653,7 @@
           <a:bodyPr wrap="square" rtlCol="0" anchor="ctr"/>
           <a:lstStyle/>
           <a:p>
-            <a:pPr indent="0" marL="0">
+            <a:pPr marL="0" indent="0">
               <a:buNone/>
             </a:pPr>
             <a:r>
@@ -10042,7 +9717,7 @@
           <a:bodyPr wrap="square" rtlCol="0" anchor="ctr"/>
           <a:lstStyle/>
           <a:p>
-            <a:pPr indent="0" marL="0">
+            <a:pPr marL="0" indent="0">
               <a:buNone/>
             </a:pPr>
             <a:r>
@@ -10106,7 +9781,7 @@
           <a:bodyPr wrap="square" rtlCol="0" anchor="ctr"/>
           <a:lstStyle/>
           <a:p>
-            <a:pPr indent="0" marL="0">
+            <a:pPr marL="0" indent="0">
               <a:buNone/>
             </a:pPr>
             <a:r>
@@ -10170,7 +9845,7 @@
           <a:bodyPr wrap="square" rtlCol="0" anchor="ctr"/>
           <a:lstStyle/>
           <a:p>
-            <a:pPr indent="0" marL="0">
+            <a:pPr marL="0" indent="0">
               <a:buNone/>
             </a:pPr>
             <a:r>
@@ -10234,7 +9909,7 @@
           <a:bodyPr wrap="square" rtlCol="0" anchor="ctr"/>
           <a:lstStyle/>
           <a:p>
-            <a:pPr indent="0" marL="0">
+            <a:pPr marL="0" indent="0">
               <a:buNone/>
             </a:pPr>
             <a:r>
@@ -10298,7 +9973,7 @@
           <a:bodyPr wrap="square" rtlCol="0" anchor="ctr"/>
           <a:lstStyle/>
           <a:p>
-            <a:pPr indent="0" marL="0">
+            <a:pPr marL="0" indent="0">
               <a:buNone/>
             </a:pPr>
             <a:r>
@@ -10362,7 +10037,7 @@
           <a:bodyPr wrap="square" rtlCol="0" anchor="ctr"/>
           <a:lstStyle/>
           <a:p>
-            <a:pPr indent="0" marL="0">
+            <a:pPr marL="0" indent="0">
               <a:buNone/>
             </a:pPr>
             <a:r>
@@ -10426,7 +10101,7 @@
           <a:bodyPr wrap="square" rtlCol="0" anchor="ctr"/>
           <a:lstStyle/>
           <a:p>
-            <a:pPr indent="0" marL="0">
+            <a:pPr marL="0" indent="0">
               <a:buNone/>
             </a:pPr>
             <a:r>
@@ -10490,7 +10165,7 @@
           <a:bodyPr wrap="square" rtlCol="0" anchor="ctr"/>
           <a:lstStyle/>
           <a:p>
-            <a:pPr indent="0" marL="0">
+            <a:pPr marL="0" indent="0">
               <a:buNone/>
             </a:pPr>
             <a:r>
@@ -10554,7 +10229,7 @@
           <a:bodyPr wrap="square" rtlCol="0" anchor="ctr"/>
           <a:lstStyle/>
           <a:p>
-            <a:pPr indent="0" marL="0">
+            <a:pPr marL="0" indent="0">
               <a:buNone/>
             </a:pPr>
             <a:r>
@@ -10618,7 +10293,7 @@
           <a:bodyPr wrap="square" rtlCol="0" anchor="ctr"/>
           <a:lstStyle/>
           <a:p>
-            <a:pPr indent="0" marL="0">
+            <a:pPr marL="0" indent="0">
               <a:buNone/>
             </a:pPr>
             <a:r>
@@ -10682,7 +10357,7 @@
           <a:bodyPr wrap="square" rtlCol="0" anchor="ctr"/>
           <a:lstStyle/>
           <a:p>
-            <a:pPr indent="0" marL="0">
+            <a:pPr marL="0" indent="0">
               <a:buNone/>
             </a:pPr>
             <a:r>
@@ -10746,7 +10421,7 @@
           <a:bodyPr wrap="square" rtlCol="0" anchor="ctr"/>
           <a:lstStyle/>
           <a:p>
-            <a:pPr indent="0" marL="0">
+            <a:pPr marL="0" indent="0">
               <a:buNone/>
             </a:pPr>
             <a:r>
@@ -10810,7 +10485,7 @@
           <a:bodyPr wrap="square" rtlCol="0" anchor="ctr"/>
           <a:lstStyle/>
           <a:p>
-            <a:pPr indent="0" marL="0">
+            <a:pPr marL="0" indent="0">
               <a:buNone/>
             </a:pPr>
             <a:r>
@@ -10874,7 +10549,7 @@
           <a:bodyPr wrap="square" rtlCol="0" anchor="ctr"/>
           <a:lstStyle/>
           <a:p>
-            <a:pPr indent="0" marL="0">
+            <a:pPr marL="0" indent="0">
               <a:buNone/>
             </a:pPr>
             <a:r>
@@ -10938,7 +10613,7 @@
           <a:bodyPr wrap="square" rtlCol="0" anchor="ctr"/>
           <a:lstStyle/>
           <a:p>
-            <a:pPr indent="0" marL="0">
+            <a:pPr marL="0" indent="0">
               <a:buNone/>
             </a:pPr>
             <a:r>
@@ -11002,7 +10677,7 @@
           <a:bodyPr wrap="square" rtlCol="0" anchor="ctr"/>
           <a:lstStyle/>
           <a:p>
-            <a:pPr indent="0" marL="0">
+            <a:pPr marL="0" indent="0">
               <a:buNone/>
             </a:pPr>
             <a:r>
@@ -11066,7 +10741,7 @@
           <a:bodyPr wrap="square" rtlCol="0" anchor="ctr"/>
           <a:lstStyle/>
           <a:p>
-            <a:pPr indent="0" marL="0">
+            <a:pPr marL="0" indent="0">
               <a:buNone/>
             </a:pPr>
             <a:r>
@@ -11130,7 +10805,7 @@
           <a:bodyPr wrap="square" rtlCol="0" anchor="ctr"/>
           <a:lstStyle/>
           <a:p>
-            <a:pPr indent="0" marL="0">
+            <a:pPr marL="0" indent="0">
               <a:buNone/>
             </a:pPr>
             <a:r>
@@ -11194,7 +10869,7 @@
           <a:bodyPr wrap="square" rtlCol="0" anchor="ctr"/>
           <a:lstStyle/>
           <a:p>
-            <a:pPr indent="0" marL="0">
+            <a:pPr marL="0" indent="0">
               <a:buNone/>
             </a:pPr>
             <a:r>
@@ -11233,7 +10908,7 @@
           <a:bodyPr wrap="square" rtlCol="0" anchor="ctr"/>
           <a:lstStyle/>
           <a:p>
-            <a:pPr indent="0" marL="0">
+            <a:pPr marL="0" indent="0">
               <a:buNone/>
             </a:pPr>
             <a:r>
@@ -11267,6 +10942,7 @@
         <a:solidFill>
           <a:srgbClr val="F5FBF7"/>
         </a:solidFill>
+        <a:effectLst/>
       </p:bgPr>
     </p:bg>
     <p:spTree>
@@ -11329,7 +11005,7 @@
           <a:bodyPr wrap="square" rtlCol="0" anchor="ctr"/>
           <a:lstStyle/>
           <a:p>
-            <a:pPr indent="0" marL="0">
+            <a:pPr marL="0" indent="0">
               <a:buNone/>
             </a:pPr>
             <a:r>
@@ -11368,7 +11044,7 @@
           <a:bodyPr wrap="square" rtlCol="0" anchor="ctr"/>
           <a:lstStyle/>
           <a:p>
-            <a:pPr indent="0" marL="0">
+            <a:pPr marL="0" indent="0">
               <a:buNone/>
             </a:pPr>
             <a:r>
@@ -11537,7 +11213,7 @@
             <a:prstDash val="solid"/>
           </a:ln>
           <a:effectLst>
-            <a:outerShdw sx="100000" sy="100000" kx="0" ky="0" algn="bl" rotWithShape="0" blurRad="101600" dist="38100" dir="8100000">
+            <a:outerShdw blurRad="101600" dist="38100" dir="8100000" algn="bl" rotWithShape="0">
               <a:srgbClr val="000000">
                 <a:alpha val="25000"/>
               </a:srgbClr>
@@ -11566,7 +11242,7 @@
           <a:bodyPr wrap="square" rtlCol="0" anchor="ctr"/>
           <a:lstStyle/>
           <a:p>
-            <a:pPr indent="0" marL="0">
+            <a:pPr marL="0" indent="0">
               <a:buNone/>
             </a:pPr>
             <a:r>
@@ -11583,7 +11259,7 @@
             <a:endParaRPr lang="en-US" sz="950" dirty="0"/>
           </a:p>
           <a:p>
-            <a:pPr indent="0" marL="0">
+            <a:pPr marL="0" indent="0">
               <a:buNone/>
             </a:pPr>
             <a:r>
@@ -11600,7 +11276,7 @@
             <a:endParaRPr lang="en-US" sz="950" dirty="0"/>
           </a:p>
           <a:p>
-            <a:pPr indent="0" marL="0">
+            <a:pPr marL="0" indent="0">
               <a:buNone/>
             </a:pPr>
             <a:r>
@@ -11617,7 +11293,7 @@
             <a:endParaRPr lang="en-US" sz="950" dirty="0"/>
           </a:p>
           <a:p>
-            <a:pPr indent="0" marL="0">
+            <a:pPr marL="0" indent="0">
               <a:buNone/>
             </a:pPr>
             <a:r>
@@ -11634,13 +11310,13 @@
             <a:endParaRPr lang="en-US" sz="950" dirty="0"/>
           </a:p>
           <a:p>
-            <a:pPr indent="0" marL="0">
+            <a:pPr marL="0" indent="0">
               <a:buNone/>
             </a:pPr>
             <a:endParaRPr lang="en-US" sz="950" dirty="0"/>
           </a:p>
           <a:p>
-            <a:pPr indent="0" marL="0">
+            <a:pPr marL="0" indent="0">
               <a:buNone/>
             </a:pPr>
             <a:r>
@@ -11657,7 +11333,7 @@
             <a:endParaRPr lang="en-US" sz="950" dirty="0"/>
           </a:p>
           <a:p>
-            <a:pPr indent="0" marL="0">
+            <a:pPr marL="0" indent="0">
               <a:buNone/>
             </a:pPr>
             <a:r>
@@ -11674,7 +11350,7 @@
             <a:endParaRPr lang="en-US" sz="950" dirty="0"/>
           </a:p>
           <a:p>
-            <a:pPr indent="0" marL="0">
+            <a:pPr marL="0" indent="0">
               <a:buNone/>
             </a:pPr>
             <a:r>
@@ -11691,7 +11367,7 @@
             <a:endParaRPr lang="en-US" sz="950" dirty="0"/>
           </a:p>
           <a:p>
-            <a:pPr indent="0" marL="0">
+            <a:pPr marL="0" indent="0">
               <a:buNone/>
             </a:pPr>
             <a:r>
@@ -11755,7 +11431,7 @@
           <a:bodyPr wrap="square" rtlCol="0" anchor="ctr"/>
           <a:lstStyle/>
           <a:p>
-            <a:pPr indent="0" marL="0">
+            <a:pPr marL="0" indent="0">
               <a:buNone/>
             </a:pPr>
             <a:r>
@@ -11789,6 +11465,7 @@
         <a:solidFill>
           <a:srgbClr val="1A3A2A"/>
         </a:solidFill>
+        <a:effectLst/>
       </p:bgPr>
     </p:bg>
     <p:spTree>
@@ -11826,7 +11503,7 @@
           <a:bodyPr wrap="square" rtlCol="0" anchor="ctr"/>
           <a:lstStyle/>
           <a:p>
-            <a:pPr indent="0" marL="0">
+            <a:pPr marL="0" indent="0">
               <a:buNone/>
             </a:pPr>
             <a:r>
@@ -11865,11 +11542,11 @@
           <a:bodyPr wrap="square" rtlCol="0" anchor="ctr"/>
           <a:lstStyle/>
           <a:p>
-            <a:pPr indent="0" marL="0">
-              <a:buNone/>
-            </a:pPr>
-            <a:r>
-              <a:rPr lang="en-US" sz="900" b="1" spc="400" kern="0" dirty="0">
+            <a:pPr marL="0" indent="0">
+              <a:buNone/>
+            </a:pPr>
+            <a:r>
+              <a:rPr lang="en-US" sz="900" b="1" kern="0" spc="400" dirty="0">
                 <a:solidFill>
                   <a:srgbClr val="A8D8B0"/>
                 </a:solidFill>
@@ -11904,7 +11581,7 @@
           <a:bodyPr wrap="square" rtlCol="0" anchor="ctr"/>
           <a:lstStyle/>
           <a:p>
-            <a:pPr indent="0" marL="0">
+            <a:pPr marL="0" indent="0">
               <a:buNone/>
             </a:pPr>
             <a:r>
@@ -11943,7 +11620,7 @@
           <a:bodyPr wrap="square" rtlCol="0" anchor="ctr"/>
           <a:lstStyle/>
           <a:p>
-            <a:pPr indent="0" marL="0">
+            <a:pPr marL="0" indent="0">
               <a:buNone/>
             </a:pPr>
             <a:r>
@@ -11982,7 +11659,7 @@
           <a:bodyPr wrap="square" rtlCol="0" anchor="ctr"/>
           <a:lstStyle/>
           <a:p>
-            <a:pPr indent="0" marL="0">
+            <a:pPr marL="0" indent="0">
               <a:buNone/>
             </a:pPr>
             <a:r>
@@ -12016,6 +11693,7 @@
         <a:solidFill>
           <a:srgbClr val="1A3A2A"/>
         </a:solidFill>
+        <a:effectLst/>
       </p:bgPr>
     </p:bg>
     <p:spTree>
@@ -12078,7 +11756,7 @@
           <a:bodyPr wrap="square" rtlCol="0" anchor="ctr"/>
           <a:lstStyle/>
           <a:p>
-            <a:pPr algn="ctr" indent="0" marL="0">
+            <a:pPr marL="0" indent="0" algn="ctr">
               <a:buNone/>
             </a:pPr>
             <a:r>
@@ -12117,7 +11795,7 @@
           <a:bodyPr wrap="square" rtlCol="0" anchor="ctr"/>
           <a:lstStyle/>
           <a:p>
-            <a:pPr indent="0" marL="0">
+            <a:pPr marL="0" indent="0">
               <a:buNone/>
             </a:pPr>
             <a:r>
@@ -12156,7 +11834,7 @@
           <a:bodyPr wrap="square" rtlCol="0" anchor="ctr"/>
           <a:lstStyle/>
           <a:p>
-            <a:pPr indent="0" marL="0">
+            <a:pPr marL="0" indent="0">
               <a:buNone/>
             </a:pPr>
             <a:r>
@@ -12292,7 +11970,7 @@
             <a:prstDash val="solid"/>
           </a:ln>
           <a:effectLst>
-            <a:outerShdw sx="100000" sy="100000" kx="0" ky="0" algn="bl" rotWithShape="0" blurRad="101600" dist="38100" dir="8100000">
+            <a:outerShdw blurRad="101600" dist="38100" dir="8100000" algn="bl" rotWithShape="0">
               <a:srgbClr val="000000">
                 <a:alpha val="25000"/>
               </a:srgbClr>
@@ -12321,7 +11999,7 @@
           <a:bodyPr wrap="square" rtlCol="0" anchor="ctr"/>
           <a:lstStyle/>
           <a:p>
-            <a:pPr indent="0" marL="0">
+            <a:pPr marL="0" indent="0">
               <a:buNone/>
             </a:pPr>
             <a:r>
@@ -12338,7 +12016,7 @@
             <a:endParaRPr lang="en-US" sz="900" dirty="0"/>
           </a:p>
           <a:p>
-            <a:pPr indent="0" marL="0">
+            <a:pPr marL="0" indent="0">
               <a:buNone/>
             </a:pPr>
             <a:r>
@@ -12355,7 +12033,7 @@
             <a:endParaRPr lang="en-US" sz="900" dirty="0"/>
           </a:p>
           <a:p>
-            <a:pPr indent="0" marL="0">
+            <a:pPr marL="0" indent="0">
               <a:buNone/>
             </a:pPr>
             <a:r>
@@ -12372,7 +12050,7 @@
             <a:endParaRPr lang="en-US" sz="900" dirty="0"/>
           </a:p>
           <a:p>
-            <a:pPr indent="0" marL="0">
+            <a:pPr marL="0" indent="0">
               <a:buNone/>
             </a:pPr>
             <a:r>
@@ -12389,7 +12067,7 @@
             <a:endParaRPr lang="en-US" sz="900" dirty="0"/>
           </a:p>
           <a:p>
-            <a:pPr indent="0" marL="0">
+            <a:pPr marL="0" indent="0">
               <a:buNone/>
             </a:pPr>
             <a:r>
@@ -12406,13 +12084,13 @@
             <a:endParaRPr lang="en-US" sz="900" dirty="0"/>
           </a:p>
           <a:p>
-            <a:pPr indent="0" marL="0">
+            <a:pPr marL="0" indent="0">
               <a:buNone/>
             </a:pPr>
             <a:endParaRPr lang="en-US" sz="900" dirty="0"/>
           </a:p>
           <a:p>
-            <a:pPr indent="0" marL="0">
+            <a:pPr marL="0" indent="0">
               <a:buNone/>
             </a:pPr>
             <a:r>
@@ -12429,7 +12107,7 @@
             <a:endParaRPr lang="en-US" sz="900" dirty="0"/>
           </a:p>
           <a:p>
-            <a:pPr indent="0" marL="0">
+            <a:pPr marL="0" indent="0">
               <a:buNone/>
             </a:pPr>
             <a:r>
@@ -12446,7 +12124,7 @@
             <a:endParaRPr lang="en-US" sz="900" dirty="0"/>
           </a:p>
           <a:p>
-            <a:pPr indent="0" marL="0">
+            <a:pPr marL="0" indent="0">
               <a:buNone/>
             </a:pPr>
             <a:r>
@@ -12485,7 +12163,7 @@
           <a:bodyPr wrap="square" rtlCol="0" anchor="ctr"/>
           <a:lstStyle/>
           <a:p>
-            <a:pPr indent="0" marL="0">
+            <a:pPr marL="0" indent="0">
               <a:buNone/>
             </a:pPr>
             <a:r>
@@ -12519,6 +12197,7 @@
         <a:solidFill>
           <a:srgbClr val="1A3A2A"/>
         </a:solidFill>
+        <a:effectLst/>
       </p:bgPr>
     </p:bg>
     <p:spTree>
@@ -12581,7 +12260,7 @@
           <a:bodyPr wrap="square" rtlCol="0" anchor="ctr"/>
           <a:lstStyle/>
           <a:p>
-            <a:pPr algn="ctr" indent="0" marL="0">
+            <a:pPr marL="0" indent="0" algn="ctr">
               <a:buNone/>
             </a:pPr>
             <a:r>
@@ -12620,7 +12299,7 @@
           <a:bodyPr wrap="square" rtlCol="0" anchor="ctr"/>
           <a:lstStyle/>
           <a:p>
-            <a:pPr indent="0" marL="0">
+            <a:pPr marL="0" indent="0">
               <a:buNone/>
             </a:pPr>
             <a:r>
@@ -12659,7 +12338,7 @@
           <a:bodyPr wrap="square" rtlCol="0" anchor="ctr"/>
           <a:lstStyle/>
           <a:p>
-            <a:pPr indent="0" marL="0">
+            <a:pPr marL="0" indent="0">
               <a:buNone/>
             </a:pPr>
             <a:r>
@@ -12795,7 +12474,7 @@
             <a:prstDash val="solid"/>
           </a:ln>
           <a:effectLst>
-            <a:outerShdw sx="100000" sy="100000" kx="0" ky="0" algn="bl" rotWithShape="0" blurRad="101600" dist="38100" dir="8100000">
+            <a:outerShdw blurRad="101600" dist="38100" dir="8100000" algn="bl" rotWithShape="0">
               <a:srgbClr val="000000">
                 <a:alpha val="25000"/>
               </a:srgbClr>
@@ -12824,7 +12503,7 @@
           <a:bodyPr wrap="square" rtlCol="0" anchor="ctr"/>
           <a:lstStyle/>
           <a:p>
-            <a:pPr indent="0" marL="0">
+            <a:pPr marL="0" indent="0">
               <a:buNone/>
             </a:pPr>
             <a:r>
@@ -12841,7 +12520,7 @@
             <a:endParaRPr lang="en-US" sz="900" dirty="0"/>
           </a:p>
           <a:p>
-            <a:pPr indent="0" marL="0">
+            <a:pPr marL="0" indent="0">
               <a:buNone/>
             </a:pPr>
             <a:r>
@@ -12858,7 +12537,7 @@
             <a:endParaRPr lang="en-US" sz="900" dirty="0"/>
           </a:p>
           <a:p>
-            <a:pPr indent="0" marL="0">
+            <a:pPr marL="0" indent="0">
               <a:buNone/>
             </a:pPr>
             <a:r>
@@ -12875,13 +12554,13 @@
             <a:endParaRPr lang="en-US" sz="900" dirty="0"/>
           </a:p>
           <a:p>
-            <a:pPr indent="0" marL="0">
+            <a:pPr marL="0" indent="0">
               <a:buNone/>
             </a:pPr>
             <a:endParaRPr lang="en-US" sz="900" dirty="0"/>
           </a:p>
           <a:p>
-            <a:pPr indent="0" marL="0">
+            <a:pPr marL="0" indent="0">
               <a:buNone/>
             </a:pPr>
             <a:r>
@@ -12898,7 +12577,7 @@
             <a:endParaRPr lang="en-US" sz="900" dirty="0"/>
           </a:p>
           <a:p>
-            <a:pPr indent="0" marL="0">
+            <a:pPr marL="0" indent="0">
               <a:buNone/>
             </a:pPr>
             <a:r>
@@ -12915,7 +12594,7 @@
             <a:endParaRPr lang="en-US" sz="900" dirty="0"/>
           </a:p>
           <a:p>
-            <a:pPr indent="0" marL="0">
+            <a:pPr marL="0" indent="0">
               <a:buNone/>
             </a:pPr>
             <a:r>
@@ -12932,7 +12611,7 @@
             <a:endParaRPr lang="en-US" sz="900" dirty="0"/>
           </a:p>
           <a:p>
-            <a:pPr indent="0" marL="0">
+            <a:pPr marL="0" indent="0">
               <a:buNone/>
             </a:pPr>
             <a:r>
@@ -12949,7 +12628,7 @@
             <a:endParaRPr lang="en-US" sz="900" dirty="0"/>
           </a:p>
           <a:p>
-            <a:pPr indent="0" marL="0">
+            <a:pPr marL="0" indent="0">
               <a:buNone/>
             </a:pPr>
             <a:r>
@@ -12966,7 +12645,7 @@
             <a:endParaRPr lang="en-US" sz="900" dirty="0"/>
           </a:p>
           <a:p>
-            <a:pPr indent="0" marL="0">
+            <a:pPr marL="0" indent="0">
               <a:buNone/>
             </a:pPr>
             <a:r>
@@ -13005,7 +12684,7 @@
           <a:bodyPr wrap="square" rtlCol="0" anchor="ctr"/>
           <a:lstStyle/>
           <a:p>
-            <a:pPr indent="0" marL="0">
+            <a:pPr marL="0" indent="0">
               <a:buNone/>
             </a:pPr>
             <a:r>
@@ -13039,6 +12718,7 @@
         <a:solidFill>
           <a:srgbClr val="1A3A2A"/>
         </a:solidFill>
+        <a:effectLst/>
       </p:bgPr>
     </p:bg>
     <p:spTree>
@@ -13101,7 +12781,7 @@
           <a:bodyPr wrap="square" rtlCol="0" anchor="ctr"/>
           <a:lstStyle/>
           <a:p>
-            <a:pPr algn="ctr" indent="0" marL="0">
+            <a:pPr marL="0" indent="0" algn="ctr">
               <a:buNone/>
             </a:pPr>
             <a:r>
@@ -13140,7 +12820,7 @@
           <a:bodyPr wrap="square" rtlCol="0" anchor="ctr"/>
           <a:lstStyle/>
           <a:p>
-            <a:pPr indent="0" marL="0">
+            <a:pPr marL="0" indent="0">
               <a:buNone/>
             </a:pPr>
             <a:r>
@@ -13179,7 +12859,7 @@
           <a:bodyPr wrap="square" rtlCol="0" anchor="ctr"/>
           <a:lstStyle/>
           <a:p>
-            <a:pPr indent="0" marL="0">
+            <a:pPr marL="0" indent="0">
               <a:buNone/>
             </a:pPr>
             <a:r>
@@ -13315,7 +12995,7 @@
             <a:prstDash val="solid"/>
           </a:ln>
           <a:effectLst>
-            <a:outerShdw sx="100000" sy="100000" kx="0" ky="0" algn="bl" rotWithShape="0" blurRad="101600" dist="38100" dir="8100000">
+            <a:outerShdw blurRad="101600" dist="38100" dir="8100000" algn="bl" rotWithShape="0">
               <a:srgbClr val="000000">
                 <a:alpha val="25000"/>
               </a:srgbClr>
@@ -13344,7 +13024,7 @@
           <a:bodyPr wrap="square" rtlCol="0" anchor="ctr"/>
           <a:lstStyle/>
           <a:p>
-            <a:pPr indent="0" marL="0">
+            <a:pPr marL="0" indent="0">
               <a:buNone/>
             </a:pPr>
             <a:r>
@@ -13361,7 +13041,7 @@
             <a:endParaRPr lang="en-US" sz="900" dirty="0"/>
           </a:p>
           <a:p>
-            <a:pPr indent="0" marL="0">
+            <a:pPr marL="0" indent="0">
               <a:buNone/>
             </a:pPr>
             <a:r>
@@ -13378,7 +13058,7 @@
             <a:endParaRPr lang="en-US" sz="900" dirty="0"/>
           </a:p>
           <a:p>
-            <a:pPr indent="0" marL="0">
+            <a:pPr marL="0" indent="0">
               <a:buNone/>
             </a:pPr>
             <a:r>
@@ -13395,13 +13075,13 @@
             <a:endParaRPr lang="en-US" sz="900" dirty="0"/>
           </a:p>
           <a:p>
-            <a:pPr indent="0" marL="0">
+            <a:pPr marL="0" indent="0">
               <a:buNone/>
             </a:pPr>
             <a:endParaRPr lang="en-US" sz="900" dirty="0"/>
           </a:p>
           <a:p>
-            <a:pPr indent="0" marL="0">
+            <a:pPr marL="0" indent="0">
               <a:buNone/>
             </a:pPr>
             <a:r>
@@ -13418,7 +13098,7 @@
             <a:endParaRPr lang="en-US" sz="900" dirty="0"/>
           </a:p>
           <a:p>
-            <a:pPr indent="0" marL="0">
+            <a:pPr marL="0" indent="0">
               <a:buNone/>
             </a:pPr>
             <a:r>
@@ -13435,7 +13115,7 @@
             <a:endParaRPr lang="en-US" sz="900" dirty="0"/>
           </a:p>
           <a:p>
-            <a:pPr indent="0" marL="0">
+            <a:pPr marL="0" indent="0">
               <a:buNone/>
             </a:pPr>
             <a:r>
@@ -13452,7 +13132,7 @@
             <a:endParaRPr lang="en-US" sz="900" dirty="0"/>
           </a:p>
           <a:p>
-            <a:pPr indent="0" marL="0">
+            <a:pPr marL="0" indent="0">
               <a:buNone/>
             </a:pPr>
             <a:r>
@@ -13469,7 +13149,7 @@
             <a:endParaRPr lang="en-US" sz="900" dirty="0"/>
           </a:p>
           <a:p>
-            <a:pPr indent="0" marL="0">
+            <a:pPr marL="0" indent="0">
               <a:buNone/>
             </a:pPr>
             <a:r>
@@ -13486,7 +13166,7 @@
             <a:endParaRPr lang="en-US" sz="900" dirty="0"/>
           </a:p>
           <a:p>
-            <a:pPr indent="0" marL="0">
+            <a:pPr marL="0" indent="0">
               <a:buNone/>
             </a:pPr>
             <a:r>
@@ -13503,7 +13183,7 @@
             <a:endParaRPr lang="en-US" sz="900" dirty="0"/>
           </a:p>
           <a:p>
-            <a:pPr indent="0" marL="0">
+            <a:pPr marL="0" indent="0">
               <a:buNone/>
             </a:pPr>
             <a:r>
@@ -13520,7 +13200,7 @@
             <a:endParaRPr lang="en-US" sz="900" dirty="0"/>
           </a:p>
           <a:p>
-            <a:pPr indent="0" marL="0">
+            <a:pPr marL="0" indent="0">
               <a:buNone/>
             </a:pPr>
             <a:r>
@@ -13559,7 +13239,7 @@
           <a:bodyPr wrap="square" rtlCol="0" anchor="ctr"/>
           <a:lstStyle/>
           <a:p>
-            <a:pPr indent="0" marL="0">
+            <a:pPr marL="0" indent="0">
               <a:buNone/>
             </a:pPr>
             <a:r>
@@ -13593,6 +13273,7 @@
         <a:solidFill>
           <a:srgbClr val="1A3A2A"/>
         </a:solidFill>
+        <a:effectLst/>
       </p:bgPr>
     </p:bg>
     <p:spTree>
@@ -13655,7 +13336,7 @@
           <a:bodyPr wrap="square" rtlCol="0" anchor="ctr"/>
           <a:lstStyle/>
           <a:p>
-            <a:pPr algn="ctr" indent="0" marL="0">
+            <a:pPr marL="0" indent="0" algn="ctr">
               <a:buNone/>
             </a:pPr>
             <a:r>
@@ -13694,7 +13375,7 @@
           <a:bodyPr wrap="square" rtlCol="0" anchor="ctr"/>
           <a:lstStyle/>
           <a:p>
-            <a:pPr indent="0" marL="0">
+            <a:pPr marL="0" indent="0">
               <a:buNone/>
             </a:pPr>
             <a:r>
@@ -13733,7 +13414,7 @@
           <a:bodyPr wrap="square" rtlCol="0" anchor="ctr"/>
           <a:lstStyle/>
           <a:p>
-            <a:pPr indent="0" marL="0">
+            <a:pPr marL="0" indent="0">
               <a:buNone/>
             </a:pPr>
             <a:r>
@@ -13869,7 +13550,7 @@
             <a:prstDash val="solid"/>
           </a:ln>
           <a:effectLst>
-            <a:outerShdw sx="100000" sy="100000" kx="0" ky="0" algn="bl" rotWithShape="0" blurRad="101600" dist="38100" dir="8100000">
+            <a:outerShdw blurRad="101600" dist="38100" dir="8100000" algn="bl" rotWithShape="0">
               <a:srgbClr val="000000">
                 <a:alpha val="25000"/>
               </a:srgbClr>
@@ -13898,7 +13579,7 @@
           <a:bodyPr wrap="square" rtlCol="0" anchor="ctr"/>
           <a:lstStyle/>
           <a:p>
-            <a:pPr indent="0" marL="0">
+            <a:pPr marL="0" indent="0">
               <a:buNone/>
             </a:pPr>
             <a:r>
@@ -13915,7 +13596,7 @@
             <a:endParaRPr lang="en-US" sz="900" dirty="0"/>
           </a:p>
           <a:p>
-            <a:pPr indent="0" marL="0">
+            <a:pPr marL="0" indent="0">
               <a:buNone/>
             </a:pPr>
             <a:r>
@@ -13932,13 +13613,13 @@
             <a:endParaRPr lang="en-US" sz="900" dirty="0"/>
           </a:p>
           <a:p>
-            <a:pPr indent="0" marL="0">
+            <a:pPr marL="0" indent="0">
               <a:buNone/>
             </a:pPr>
             <a:endParaRPr lang="en-US" sz="900" dirty="0"/>
           </a:p>
           <a:p>
-            <a:pPr indent="0" marL="0">
+            <a:pPr marL="0" indent="0">
               <a:buNone/>
             </a:pPr>
             <a:r>
@@ -13955,7 +13636,7 @@
             <a:endParaRPr lang="en-US" sz="900" dirty="0"/>
           </a:p>
           <a:p>
-            <a:pPr indent="0" marL="0">
+            <a:pPr marL="0" indent="0">
               <a:buNone/>
             </a:pPr>
             <a:r>
@@ -13972,7 +13653,7 @@
             <a:endParaRPr lang="en-US" sz="900" dirty="0"/>
           </a:p>
           <a:p>
-            <a:pPr indent="0" marL="0">
+            <a:pPr marL="0" indent="0">
               <a:buNone/>
             </a:pPr>
             <a:r>
@@ -13989,7 +13670,7 @@
             <a:endParaRPr lang="en-US" sz="900" dirty="0"/>
           </a:p>
           <a:p>
-            <a:pPr indent="0" marL="0">
+            <a:pPr marL="0" indent="0">
               <a:buNone/>
             </a:pPr>
             <a:r>
@@ -14006,7 +13687,7 @@
             <a:endParaRPr lang="en-US" sz="900" dirty="0"/>
           </a:p>
           <a:p>
-            <a:pPr indent="0" marL="0">
+            <a:pPr marL="0" indent="0">
               <a:buNone/>
             </a:pPr>
             <a:r>
@@ -14023,7 +13704,7 @@
             <a:endParaRPr lang="en-US" sz="900" dirty="0"/>
           </a:p>
           <a:p>
-            <a:pPr indent="0" marL="0">
+            <a:pPr marL="0" indent="0">
               <a:buNone/>
             </a:pPr>
             <a:r>
@@ -14062,7 +13743,7 @@
           <a:bodyPr wrap="square" rtlCol="0" anchor="ctr"/>
           <a:lstStyle/>
           <a:p>
-            <a:pPr indent="0" marL="0">
+            <a:pPr marL="0" indent="0">
               <a:buNone/>
             </a:pPr>
             <a:r>
@@ -14096,6 +13777,7 @@
         <a:solidFill>
           <a:srgbClr val="1A3A2A"/>
         </a:solidFill>
+        <a:effectLst/>
       </p:bgPr>
     </p:bg>
     <p:spTree>
@@ -14158,7 +13840,7 @@
           <a:bodyPr wrap="square" rtlCol="0" anchor="ctr"/>
           <a:lstStyle/>
           <a:p>
-            <a:pPr algn="ctr" indent="0" marL="0">
+            <a:pPr marL="0" indent="0" algn="ctr">
               <a:buNone/>
             </a:pPr>
             <a:r>
@@ -14197,7 +13879,7 @@
           <a:bodyPr wrap="square" rtlCol="0" anchor="ctr"/>
           <a:lstStyle/>
           <a:p>
-            <a:pPr indent="0" marL="0">
+            <a:pPr marL="0" indent="0">
               <a:buNone/>
             </a:pPr>
             <a:r>
@@ -14236,7 +13918,7 @@
           <a:bodyPr wrap="square" rtlCol="0" anchor="ctr"/>
           <a:lstStyle/>
           <a:p>
-            <a:pPr indent="0" marL="0">
+            <a:pPr marL="0" indent="0">
               <a:buNone/>
             </a:pPr>
             <a:r>
@@ -14372,7 +14054,7 @@
             <a:prstDash val="solid"/>
           </a:ln>
           <a:effectLst>
-            <a:outerShdw sx="100000" sy="100000" kx="0" ky="0" algn="bl" rotWithShape="0" blurRad="101600" dist="38100" dir="8100000">
+            <a:outerShdw blurRad="101600" dist="38100" dir="8100000" algn="bl" rotWithShape="0">
               <a:srgbClr val="000000">
                 <a:alpha val="25000"/>
               </a:srgbClr>
@@ -14401,7 +14083,7 @@
           <a:bodyPr wrap="square" rtlCol="0" anchor="ctr"/>
           <a:lstStyle/>
           <a:p>
-            <a:pPr indent="0" marL="0">
+            <a:pPr marL="0" indent="0">
               <a:buNone/>
             </a:pPr>
             <a:r>
@@ -14418,7 +14100,7 @@
             <a:endParaRPr lang="en-US" sz="900" dirty="0"/>
           </a:p>
           <a:p>
-            <a:pPr indent="0" marL="0">
+            <a:pPr marL="0" indent="0">
               <a:buNone/>
             </a:pPr>
             <a:r>
@@ -14435,7 +14117,7 @@
             <a:endParaRPr lang="en-US" sz="900" dirty="0"/>
           </a:p>
           <a:p>
-            <a:pPr indent="0" marL="0">
+            <a:pPr marL="0" indent="0">
               <a:buNone/>
             </a:pPr>
             <a:r>
@@ -14452,7 +14134,7 @@
             <a:endParaRPr lang="en-US" sz="900" dirty="0"/>
           </a:p>
           <a:p>
-            <a:pPr indent="0" marL="0">
+            <a:pPr marL="0" indent="0">
               <a:buNone/>
             </a:pPr>
             <a:r>
@@ -14469,7 +14151,7 @@
             <a:endParaRPr lang="en-US" sz="900" dirty="0"/>
           </a:p>
           <a:p>
-            <a:pPr indent="0" marL="0">
+            <a:pPr marL="0" indent="0">
               <a:buNone/>
             </a:pPr>
             <a:r>
@@ -14486,7 +14168,7 @@
             <a:endParaRPr lang="en-US" sz="900" dirty="0"/>
           </a:p>
           <a:p>
-            <a:pPr indent="0" marL="0">
+            <a:pPr marL="0" indent="0">
               <a:buNone/>
             </a:pPr>
             <a:r>
@@ -14503,7 +14185,7 @@
             <a:endParaRPr lang="en-US" sz="900" dirty="0"/>
           </a:p>
           <a:p>
-            <a:pPr indent="0" marL="0">
+            <a:pPr marL="0" indent="0">
               <a:buNone/>
             </a:pPr>
             <a:r>
@@ -14520,7 +14202,7 @@
             <a:endParaRPr lang="en-US" sz="900" dirty="0"/>
           </a:p>
           <a:p>
-            <a:pPr indent="0" marL="0">
+            <a:pPr marL="0" indent="0">
               <a:buNone/>
             </a:pPr>
             <a:r>
@@ -14537,7 +14219,7 @@
             <a:endParaRPr lang="en-US" sz="900" dirty="0"/>
           </a:p>
           <a:p>
-            <a:pPr indent="0" marL="0">
+            <a:pPr marL="0" indent="0">
               <a:buNone/>
             </a:pPr>
             <a:r>
@@ -14554,7 +14236,7 @@
             <a:endParaRPr lang="en-US" sz="900" dirty="0"/>
           </a:p>
           <a:p>
-            <a:pPr indent="0" marL="0">
+            <a:pPr marL="0" indent="0">
               <a:buNone/>
             </a:pPr>
             <a:r>
@@ -14571,7 +14253,7 @@
             <a:endParaRPr lang="en-US" sz="900" dirty="0"/>
           </a:p>
           <a:p>
-            <a:pPr indent="0" marL="0">
+            <a:pPr marL="0" indent="0">
               <a:buNone/>
             </a:pPr>
             <a:r>
@@ -14588,7 +14270,7 @@
             <a:endParaRPr lang="en-US" sz="900" dirty="0"/>
           </a:p>
           <a:p>
-            <a:pPr indent="0" marL="0">
+            <a:pPr marL="0" indent="0">
               <a:buNone/>
             </a:pPr>
             <a:r>
@@ -14627,7 +14309,7 @@
           <a:bodyPr wrap="square" rtlCol="0" anchor="ctr"/>
           <a:lstStyle/>
           <a:p>
-            <a:pPr indent="0" marL="0">
+            <a:pPr marL="0" indent="0">
               <a:buNone/>
             </a:pPr>
             <a:r>
@@ -14661,6 +14343,7 @@
         <a:solidFill>
           <a:srgbClr val="1A3A2A"/>
         </a:solidFill>
+        <a:effectLst/>
       </p:bgPr>
     </p:bg>
     <p:spTree>
@@ -14723,7 +14406,7 @@
           <a:bodyPr wrap="square" rtlCol="0" anchor="ctr"/>
           <a:lstStyle/>
           <a:p>
-            <a:pPr algn="ctr" indent="0" marL="0">
+            <a:pPr marL="0" indent="0" algn="ctr">
               <a:buNone/>
             </a:pPr>
             <a:r>
@@ -14762,7 +14445,7 @@
           <a:bodyPr wrap="square" rtlCol="0" anchor="ctr"/>
           <a:lstStyle/>
           <a:p>
-            <a:pPr indent="0" marL="0">
+            <a:pPr marL="0" indent="0">
               <a:buNone/>
             </a:pPr>
             <a:r>
@@ -14801,7 +14484,7 @@
           <a:bodyPr wrap="square" rtlCol="0" anchor="ctr"/>
           <a:lstStyle/>
           <a:p>
-            <a:pPr indent="0" marL="0">
+            <a:pPr marL="0" indent="0">
               <a:buNone/>
             </a:pPr>
             <a:r>
@@ -14937,7 +14620,7 @@
             <a:prstDash val="solid"/>
           </a:ln>
           <a:effectLst>
-            <a:outerShdw sx="100000" sy="100000" kx="0" ky="0" algn="bl" rotWithShape="0" blurRad="101600" dist="38100" dir="8100000">
+            <a:outerShdw blurRad="101600" dist="38100" dir="8100000" algn="bl" rotWithShape="0">
               <a:srgbClr val="000000">
                 <a:alpha val="25000"/>
               </a:srgbClr>
@@ -14966,7 +14649,7 @@
           <a:bodyPr wrap="square" rtlCol="0" anchor="ctr"/>
           <a:lstStyle/>
           <a:p>
-            <a:pPr indent="0" marL="0">
+            <a:pPr marL="0" indent="0">
               <a:buNone/>
             </a:pPr>
             <a:r>
@@ -14983,7 +14666,7 @@
             <a:endParaRPr lang="en-US" sz="900" dirty="0"/>
           </a:p>
           <a:p>
-            <a:pPr indent="0" marL="0">
+            <a:pPr marL="0" indent="0">
               <a:buNone/>
             </a:pPr>
             <a:r>
@@ -15000,13 +14683,13 @@
             <a:endParaRPr lang="en-US" sz="900" dirty="0"/>
           </a:p>
           <a:p>
-            <a:pPr indent="0" marL="0">
+            <a:pPr marL="0" indent="0">
               <a:buNone/>
             </a:pPr>
             <a:endParaRPr lang="en-US" sz="900" dirty="0"/>
           </a:p>
           <a:p>
-            <a:pPr indent="0" marL="0">
+            <a:pPr marL="0" indent="0">
               <a:buNone/>
             </a:pPr>
             <a:r>
@@ -15023,7 +14706,7 @@
             <a:endParaRPr lang="en-US" sz="900" dirty="0"/>
           </a:p>
           <a:p>
-            <a:pPr indent="0" marL="0">
+            <a:pPr marL="0" indent="0">
               <a:buNone/>
             </a:pPr>
             <a:r>
@@ -15040,7 +14723,7 @@
             <a:endParaRPr lang="en-US" sz="900" dirty="0"/>
           </a:p>
           <a:p>
-            <a:pPr indent="0" marL="0">
+            <a:pPr marL="0" indent="0">
               <a:buNone/>
             </a:pPr>
             <a:r>
@@ -15057,7 +14740,7 @@
             <a:endParaRPr lang="en-US" sz="900" dirty="0"/>
           </a:p>
           <a:p>
-            <a:pPr indent="0" marL="0">
+            <a:pPr marL="0" indent="0">
               <a:buNone/>
             </a:pPr>
             <a:r>
@@ -15074,7 +14757,7 @@
             <a:endParaRPr lang="en-US" sz="900" dirty="0"/>
           </a:p>
           <a:p>
-            <a:pPr indent="0" marL="0">
+            <a:pPr marL="0" indent="0">
               <a:buNone/>
             </a:pPr>
             <a:r>
@@ -15091,7 +14774,7 @@
             <a:endParaRPr lang="en-US" sz="900" dirty="0"/>
           </a:p>
           <a:p>
-            <a:pPr indent="0" marL="0">
+            <a:pPr marL="0" indent="0">
               <a:buNone/>
             </a:pPr>
             <a:r>
@@ -15108,7 +14791,7 @@
             <a:endParaRPr lang="en-US" sz="900" dirty="0"/>
           </a:p>
           <a:p>
-            <a:pPr indent="0" marL="0">
+            <a:pPr marL="0" indent="0">
               <a:buNone/>
             </a:pPr>
             <a:r>
@@ -15125,7 +14808,7 @@
             <a:endParaRPr lang="en-US" sz="900" dirty="0"/>
           </a:p>
           <a:p>
-            <a:pPr indent="0" marL="0">
+            <a:pPr marL="0" indent="0">
               <a:buNone/>
             </a:pPr>
             <a:r>
@@ -15142,7 +14825,7 @@
             <a:endParaRPr lang="en-US" sz="900" dirty="0"/>
           </a:p>
           <a:p>
-            <a:pPr indent="0" marL="0">
+            <a:pPr marL="0" indent="0">
               <a:buNone/>
             </a:pPr>
             <a:r>
@@ -15159,7 +14842,7 @@
             <a:endParaRPr lang="en-US" sz="900" dirty="0"/>
           </a:p>
           <a:p>
-            <a:pPr indent="0" marL="0">
+            <a:pPr marL="0" indent="0">
               <a:buNone/>
             </a:pPr>
             <a:r>
@@ -15198,7 +14881,7 @@
           <a:bodyPr wrap="square" rtlCol="0" anchor="ctr"/>
           <a:lstStyle/>
           <a:p>
-            <a:pPr indent="0" marL="0">
+            <a:pPr marL="0" indent="0">
               <a:buNone/>
             </a:pPr>
             <a:r>
@@ -15232,6 +14915,7 @@
         <a:solidFill>
           <a:srgbClr val="1A3A2A"/>
         </a:solidFill>
+        <a:effectLst/>
       </p:bgPr>
     </p:bg>
     <p:spTree>
@@ -15294,7 +14978,7 @@
           <a:bodyPr wrap="square" rtlCol="0" anchor="ctr"/>
           <a:lstStyle/>
           <a:p>
-            <a:pPr algn="ctr" indent="0" marL="0">
+            <a:pPr marL="0" indent="0" algn="ctr">
               <a:buNone/>
             </a:pPr>
             <a:r>
@@ -15333,7 +15017,7 @@
           <a:bodyPr wrap="square" rtlCol="0" anchor="ctr"/>
           <a:lstStyle/>
           <a:p>
-            <a:pPr indent="0" marL="0">
+            <a:pPr marL="0" indent="0">
               <a:buNone/>
             </a:pPr>
             <a:r>
@@ -15372,7 +15056,7 @@
           <a:bodyPr wrap="square" rtlCol="0" anchor="ctr"/>
           <a:lstStyle/>
           <a:p>
-            <a:pPr indent="0" marL="0">
+            <a:pPr marL="0" indent="0">
               <a:buNone/>
             </a:pPr>
             <a:r>
@@ -15508,7 +15192,7 @@
             <a:prstDash val="solid"/>
           </a:ln>
           <a:effectLst>
-            <a:outerShdw sx="100000" sy="100000" kx="0" ky="0" algn="bl" rotWithShape="0" blurRad="101600" dist="38100" dir="8100000">
+            <a:outerShdw blurRad="101600" dist="38100" dir="8100000" algn="bl" rotWithShape="0">
               <a:srgbClr val="000000">
                 <a:alpha val="25000"/>
               </a:srgbClr>
@@ -15537,7 +15221,7 @@
           <a:bodyPr wrap="square" rtlCol="0" anchor="ctr"/>
           <a:lstStyle/>
           <a:p>
-            <a:pPr indent="0" marL="0">
+            <a:pPr marL="0" indent="0">
               <a:buNone/>
             </a:pPr>
             <a:r>
@@ -15554,7 +15238,7 @@
             <a:endParaRPr lang="en-US" sz="900" dirty="0"/>
           </a:p>
           <a:p>
-            <a:pPr indent="0" marL="0">
+            <a:pPr marL="0" indent="0">
               <a:buNone/>
             </a:pPr>
             <a:r>
@@ -15571,7 +15255,7 @@
             <a:endParaRPr lang="en-US" sz="900" dirty="0"/>
           </a:p>
           <a:p>
-            <a:pPr indent="0" marL="0">
+            <a:pPr marL="0" indent="0">
               <a:buNone/>
             </a:pPr>
             <a:r>
@@ -15588,7 +15272,7 @@
             <a:endParaRPr lang="en-US" sz="900" dirty="0"/>
           </a:p>
           <a:p>
-            <a:pPr indent="0" marL="0">
+            <a:pPr marL="0" indent="0">
               <a:buNone/>
             </a:pPr>
             <a:r>
@@ -15605,7 +15289,7 @@
             <a:endParaRPr lang="en-US" sz="900" dirty="0"/>
           </a:p>
           <a:p>
-            <a:pPr indent="0" marL="0">
+            <a:pPr marL="0" indent="0">
               <a:buNone/>
             </a:pPr>
             <a:r>
@@ -15622,7 +15306,7 @@
             <a:endParaRPr lang="en-US" sz="900" dirty="0"/>
           </a:p>
           <a:p>
-            <a:pPr indent="0" marL="0">
+            <a:pPr marL="0" indent="0">
               <a:buNone/>
             </a:pPr>
             <a:r>
@@ -15639,7 +15323,7 @@
             <a:endParaRPr lang="en-US" sz="900" dirty="0"/>
           </a:p>
           <a:p>
-            <a:pPr indent="0" marL="0">
+            <a:pPr marL="0" indent="0">
               <a:buNone/>
             </a:pPr>
             <a:r>
@@ -15656,7 +15340,7 @@
             <a:endParaRPr lang="en-US" sz="900" dirty="0"/>
           </a:p>
           <a:p>
-            <a:pPr indent="0" marL="0">
+            <a:pPr marL="0" indent="0">
               <a:buNone/>
             </a:pPr>
             <a:r>
@@ -15673,7 +15357,7 @@
             <a:endParaRPr lang="en-US" sz="900" dirty="0"/>
           </a:p>
           <a:p>
-            <a:pPr indent="0" marL="0">
+            <a:pPr marL="0" indent="0">
               <a:buNone/>
             </a:pPr>
             <a:r>
@@ -15690,7 +15374,7 @@
             <a:endParaRPr lang="en-US" sz="900" dirty="0"/>
           </a:p>
           <a:p>
-            <a:pPr indent="0" marL="0">
+            <a:pPr marL="0" indent="0">
               <a:buNone/>
             </a:pPr>
             <a:r>
@@ -15707,7 +15391,7 @@
             <a:endParaRPr lang="en-US" sz="900" dirty="0"/>
           </a:p>
           <a:p>
-            <a:pPr indent="0" marL="0">
+            <a:pPr marL="0" indent="0">
               <a:buNone/>
             </a:pPr>
             <a:r>
@@ -15724,7 +15408,7 @@
             <a:endParaRPr lang="en-US" sz="900" dirty="0"/>
           </a:p>
           <a:p>
-            <a:pPr indent="0" marL="0">
+            <a:pPr marL="0" indent="0">
               <a:buNone/>
             </a:pPr>
             <a:r>
@@ -15763,7 +15447,7 @@
           <a:bodyPr wrap="square" rtlCol="0" anchor="ctr"/>
           <a:lstStyle/>
           <a:p>
-            <a:pPr indent="0" marL="0">
+            <a:pPr marL="0" indent="0">
               <a:buNone/>
             </a:pPr>
             <a:r>
@@ -15797,6 +15481,7 @@
         <a:solidFill>
           <a:srgbClr val="1A3A2A"/>
         </a:solidFill>
+        <a:effectLst/>
       </p:bgPr>
     </p:bg>
     <p:spTree>
@@ -15834,7 +15519,7 @@
           <a:bodyPr wrap="square" rtlCol="0" anchor="ctr"/>
           <a:lstStyle/>
           <a:p>
-            <a:pPr indent="0" marL="0">
+            <a:pPr marL="0" indent="0">
               <a:buNone/>
             </a:pPr>
             <a:r>
@@ -15873,11 +15558,11 @@
           <a:bodyPr wrap="square" rtlCol="0" anchor="ctr"/>
           <a:lstStyle/>
           <a:p>
-            <a:pPr indent="0" marL="0">
-              <a:buNone/>
-            </a:pPr>
-            <a:r>
-              <a:rPr lang="en-US" sz="900" b="1" spc="400" kern="0" dirty="0">
+            <a:pPr marL="0" indent="0">
+              <a:buNone/>
+            </a:pPr>
+            <a:r>
+              <a:rPr lang="en-US" sz="900" b="1" kern="0" spc="400" dirty="0">
                 <a:solidFill>
                   <a:srgbClr val="A8D8B0"/>
                 </a:solidFill>
@@ -15912,7 +15597,7 @@
           <a:bodyPr wrap="square" rtlCol="0" anchor="ctr"/>
           <a:lstStyle/>
           <a:p>
-            <a:pPr indent="0" marL="0">
+            <a:pPr marL="0" indent="0">
               <a:buNone/>
             </a:pPr>
             <a:r>
@@ -15951,7 +15636,7 @@
           <a:bodyPr wrap="square" rtlCol="0" anchor="ctr"/>
           <a:lstStyle/>
           <a:p>
-            <a:pPr indent="0" marL="0">
+            <a:pPr marL="0" indent="0">
               <a:buNone/>
             </a:pPr>
             <a:r>
@@ -15990,7 +15675,7 @@
           <a:bodyPr wrap="square" rtlCol="0" anchor="ctr"/>
           <a:lstStyle/>
           <a:p>
-            <a:pPr indent="0" marL="0">
+            <a:pPr marL="0" indent="0">
               <a:buNone/>
             </a:pPr>
             <a:r>
@@ -16024,6 +15709,7 @@
         <a:solidFill>
           <a:srgbClr val="1A3A2A"/>
         </a:solidFill>
+        <a:effectLst/>
       </p:bgPr>
     </p:bg>
     <p:spTree>
@@ -16086,7 +15772,7 @@
           <a:bodyPr wrap="square" rtlCol="0" anchor="ctr"/>
           <a:lstStyle/>
           <a:p>
-            <a:pPr algn="ctr" indent="0" marL="0">
+            <a:pPr marL="0" indent="0" algn="ctr">
               <a:buNone/>
             </a:pPr>
             <a:r>
@@ -16125,7 +15811,7 @@
           <a:bodyPr wrap="square" rtlCol="0" anchor="ctr"/>
           <a:lstStyle/>
           <a:p>
-            <a:pPr indent="0" marL="0">
+            <a:pPr marL="0" indent="0">
               <a:buNone/>
             </a:pPr>
             <a:r>
@@ -16164,7 +15850,7 @@
           <a:bodyPr wrap="square" rtlCol="0" anchor="ctr"/>
           <a:lstStyle/>
           <a:p>
-            <a:pPr indent="0" marL="0">
+            <a:pPr marL="0" indent="0">
               <a:buNone/>
             </a:pPr>
             <a:r>
@@ -16300,7 +15986,7 @@
             <a:prstDash val="solid"/>
           </a:ln>
           <a:effectLst>
-            <a:outerShdw sx="100000" sy="100000" kx="0" ky="0" algn="bl" rotWithShape="0" blurRad="101600" dist="38100" dir="8100000">
+            <a:outerShdw blurRad="101600" dist="38100" dir="8100000" algn="bl" rotWithShape="0">
               <a:srgbClr val="000000">
                 <a:alpha val="25000"/>
               </a:srgbClr>
@@ -16329,7 +16015,7 @@
           <a:bodyPr wrap="square" rtlCol="0" anchor="ctr"/>
           <a:lstStyle/>
           <a:p>
-            <a:pPr indent="0" marL="0">
+            <a:pPr marL="0" indent="0">
               <a:buNone/>
             </a:pPr>
             <a:r>
@@ -16346,7 +16032,7 @@
             <a:endParaRPr lang="en-US" sz="900" dirty="0"/>
           </a:p>
           <a:p>
-            <a:pPr indent="0" marL="0">
+            <a:pPr marL="0" indent="0">
               <a:buNone/>
             </a:pPr>
             <a:r>
@@ -16363,13 +16049,13 @@
             <a:endParaRPr lang="en-US" sz="900" dirty="0"/>
           </a:p>
           <a:p>
-            <a:pPr indent="0" marL="0">
+            <a:pPr marL="0" indent="0">
               <a:buNone/>
             </a:pPr>
             <a:endParaRPr lang="en-US" sz="900" dirty="0"/>
           </a:p>
           <a:p>
-            <a:pPr indent="0" marL="0">
+            <a:pPr marL="0" indent="0">
               <a:buNone/>
             </a:pPr>
             <a:r>
@@ -16386,7 +16072,7 @@
             <a:endParaRPr lang="en-US" sz="900" dirty="0"/>
           </a:p>
           <a:p>
-            <a:pPr indent="0" marL="0">
+            <a:pPr marL="0" indent="0">
               <a:buNone/>
             </a:pPr>
             <a:r>
@@ -16403,7 +16089,7 @@
             <a:endParaRPr lang="en-US" sz="900" dirty="0"/>
           </a:p>
           <a:p>
-            <a:pPr indent="0" marL="0">
+            <a:pPr marL="0" indent="0">
               <a:buNone/>
             </a:pPr>
             <a:r>
@@ -16420,7 +16106,7 @@
             <a:endParaRPr lang="en-US" sz="900" dirty="0"/>
           </a:p>
           <a:p>
-            <a:pPr indent="0" marL="0">
+            <a:pPr marL="0" indent="0">
               <a:buNone/>
             </a:pPr>
             <a:r>
@@ -16437,7 +16123,7 @@
             <a:endParaRPr lang="en-US" sz="900" dirty="0"/>
           </a:p>
           <a:p>
-            <a:pPr indent="0" marL="0">
+            <a:pPr marL="0" indent="0">
               <a:buNone/>
             </a:pPr>
             <a:r>
@@ -16454,7 +16140,7 @@
             <a:endParaRPr lang="en-US" sz="900" dirty="0"/>
           </a:p>
           <a:p>
-            <a:pPr indent="0" marL="0">
+            <a:pPr marL="0" indent="0">
               <a:buNone/>
             </a:pPr>
             <a:r>
@@ -16471,7 +16157,7 @@
             <a:endParaRPr lang="en-US" sz="900" dirty="0"/>
           </a:p>
           <a:p>
-            <a:pPr indent="0" marL="0">
+            <a:pPr marL="0" indent="0">
               <a:buNone/>
             </a:pPr>
             <a:r>
@@ -16488,7 +16174,7 @@
             <a:endParaRPr lang="en-US" sz="900" dirty="0"/>
           </a:p>
           <a:p>
-            <a:pPr indent="0" marL="0">
+            <a:pPr marL="0" indent="0">
               <a:buNone/>
             </a:pPr>
             <a:r>
@@ -16527,7 +16213,7 @@
           <a:bodyPr wrap="square" rtlCol="0" anchor="ctr"/>
           <a:lstStyle/>
           <a:p>
-            <a:pPr indent="0" marL="0">
+            <a:pPr marL="0" indent="0">
               <a:buNone/>
             </a:pPr>
             <a:r>
@@ -16561,6 +16247,7 @@
         <a:solidFill>
           <a:srgbClr val="1A3A2A"/>
         </a:solidFill>
+        <a:effectLst/>
       </p:bgPr>
     </p:bg>
     <p:spTree>
@@ -16598,11 +16285,11 @@
           <a:bodyPr wrap="square" rtlCol="0" anchor="ctr"/>
           <a:lstStyle/>
           <a:p>
-            <a:pPr algn="ctr" indent="0" marL="0">
-              <a:buNone/>
-            </a:pPr>
-            <a:r>
-              <a:rPr lang="en-US" sz="1000" b="1" spc="800" kern="0" dirty="0">
+            <a:pPr marL="0" indent="0" algn="ctr">
+              <a:buNone/>
+            </a:pPr>
+            <a:r>
+              <a:rPr lang="en-US" sz="1000" b="1" kern="0" spc="800" dirty="0">
                 <a:solidFill>
                   <a:srgbClr val="2ECC71"/>
                 </a:solidFill>
@@ -16637,7 +16324,7 @@
           <a:bodyPr wrap="square" rtlCol="0" anchor="ctr"/>
           <a:lstStyle/>
           <a:p>
-            <a:pPr algn="ctr" indent="0" marL="0">
+            <a:pPr marL="0" indent="0" algn="ctr">
               <a:buNone/>
             </a:pPr>
             <a:r>
@@ -16676,7 +16363,7 @@
           <a:bodyPr wrap="square" rtlCol="0" anchor="ctr"/>
           <a:lstStyle/>
           <a:p>
-            <a:pPr algn="ctr" indent="0" marL="0">
+            <a:pPr marL="0" indent="0" algn="ctr">
               <a:buNone/>
             </a:pPr>
             <a:r>
@@ -16740,7 +16427,7 @@
           <a:bodyPr wrap="square" rtlCol="0" anchor="ctr"/>
           <a:lstStyle/>
           <a:p>
-            <a:pPr algn="ctr" indent="0" marL="0">
+            <a:pPr marL="0" indent="0" algn="ctr">
               <a:buNone/>
             </a:pPr>
             <a:r>
@@ -16804,7 +16491,7 @@
           <a:bodyPr wrap="square" rtlCol="0" anchor="ctr"/>
           <a:lstStyle/>
           <a:p>
-            <a:pPr algn="ctr" indent="0" marL="0">
+            <a:pPr marL="0" indent="0" algn="ctr">
               <a:buNone/>
             </a:pPr>
             <a:r>
@@ -16868,7 +16555,7 @@
           <a:bodyPr wrap="square" rtlCol="0" anchor="ctr"/>
           <a:lstStyle/>
           <a:p>
-            <a:pPr algn="ctr" indent="0" marL="0">
+            <a:pPr marL="0" indent="0" algn="ctr">
               <a:buNone/>
             </a:pPr>
             <a:r>
@@ -16932,7 +16619,7 @@
           <a:bodyPr wrap="square" rtlCol="0" anchor="ctr"/>
           <a:lstStyle/>
           <a:p>
-            <a:pPr algn="ctr" indent="0" marL="0">
+            <a:pPr marL="0" indent="0" algn="ctr">
               <a:buNone/>
             </a:pPr>
             <a:r>
@@ -16996,7 +16683,7 @@
           <a:bodyPr wrap="square" rtlCol="0" anchor="ctr"/>
           <a:lstStyle/>
           <a:p>
-            <a:pPr algn="ctr" indent="0" marL="0">
+            <a:pPr marL="0" indent="0" algn="ctr">
               <a:buNone/>
             </a:pPr>
             <a:r>
@@ -17060,7 +16747,7 @@
           <a:bodyPr wrap="square" rtlCol="0" anchor="ctr"/>
           <a:lstStyle/>
           <a:p>
-            <a:pPr algn="ctr" indent="0" marL="0">
+            <a:pPr marL="0" indent="0" algn="ctr">
               <a:buNone/>
             </a:pPr>
             <a:r>
@@ -17124,7 +16811,7 @@
           <a:bodyPr wrap="square" rtlCol="0" anchor="ctr"/>
           <a:lstStyle/>
           <a:p>
-            <a:pPr algn="ctr" indent="0" marL="0">
+            <a:pPr marL="0" indent="0" algn="ctr">
               <a:buNone/>
             </a:pPr>
             <a:r>
@@ -17188,7 +16875,7 @@
           <a:bodyPr wrap="square" rtlCol="0" anchor="ctr"/>
           <a:lstStyle/>
           <a:p>
-            <a:pPr algn="ctr" indent="0" marL="0">
+            <a:pPr marL="0" indent="0" algn="ctr">
               <a:buNone/>
             </a:pPr>
             <a:r>
@@ -17227,7 +16914,7 @@
           <a:bodyPr wrap="square" rtlCol="0" anchor="ctr"/>
           <a:lstStyle/>
           <a:p>
-            <a:pPr algn="ctr" indent="0" marL="0">
+            <a:pPr marL="0" indent="0" algn="ctr">
               <a:buNone/>
             </a:pPr>
             <a:r>
@@ -17261,6 +16948,7 @@
         <a:solidFill>
           <a:srgbClr val="F5FBF7"/>
         </a:solidFill>
+        <a:effectLst/>
       </p:bgPr>
     </p:bg>
     <p:spTree>
@@ -17323,7 +17011,7 @@
           <a:bodyPr wrap="square" rtlCol="0" anchor="ctr"/>
           <a:lstStyle/>
           <a:p>
-            <a:pPr indent="0" marL="0">
+            <a:pPr marL="0" indent="0">
               <a:buNone/>
             </a:pPr>
             <a:r>
@@ -17362,7 +17050,7 @@
           <a:bodyPr wrap="square" rtlCol="0" anchor="ctr"/>
           <a:lstStyle/>
           <a:p>
-            <a:pPr indent="0" marL="0">
+            <a:pPr marL="0" indent="0">
               <a:buNone/>
             </a:pPr>
             <a:r>
@@ -17510,7 +17198,7 @@
             <a:prstDash val="solid"/>
           </a:ln>
           <a:effectLst>
-            <a:outerShdw sx="100000" sy="100000" kx="0" ky="0" algn="bl" rotWithShape="0" blurRad="101600" dist="38100" dir="8100000">
+            <a:outerShdw blurRad="101600" dist="38100" dir="8100000" algn="bl" rotWithShape="0">
               <a:srgbClr val="000000">
                 <a:alpha val="25000"/>
               </a:srgbClr>
@@ -17539,7 +17227,7 @@
           <a:bodyPr wrap="square" rtlCol="0" anchor="ctr"/>
           <a:lstStyle/>
           <a:p>
-            <a:pPr indent="0" marL="0">
+            <a:pPr marL="0" indent="0">
               <a:buNone/>
             </a:pPr>
             <a:r>
@@ -17556,7 +17244,7 @@
             <a:endParaRPr lang="en-US" sz="950" dirty="0"/>
           </a:p>
           <a:p>
-            <a:pPr indent="0" marL="0">
+            <a:pPr marL="0" indent="0">
               <a:buNone/>
             </a:pPr>
             <a:r>
@@ -17573,13 +17261,13 @@
             <a:endParaRPr lang="en-US" sz="950" dirty="0"/>
           </a:p>
           <a:p>
-            <a:pPr indent="0" marL="0">
+            <a:pPr marL="0" indent="0">
               <a:buNone/>
             </a:pPr>
             <a:endParaRPr lang="en-US" sz="950" dirty="0"/>
           </a:p>
           <a:p>
-            <a:pPr indent="0" marL="0">
+            <a:pPr marL="0" indent="0">
               <a:buNone/>
             </a:pPr>
             <a:r>
@@ -17596,7 +17284,7 @@
             <a:endParaRPr lang="en-US" sz="950" dirty="0"/>
           </a:p>
           <a:p>
-            <a:pPr indent="0" marL="0">
+            <a:pPr marL="0" indent="0">
               <a:buNone/>
             </a:pPr>
             <a:r>
@@ -17660,7 +17348,7 @@
           <a:bodyPr wrap="square" rtlCol="0" anchor="ctr"/>
           <a:lstStyle/>
           <a:p>
-            <a:pPr indent="0" marL="0">
+            <a:pPr marL="0" indent="0">
               <a:buNone/>
             </a:pPr>
             <a:r>
@@ -17694,6 +17382,7 @@
         <a:solidFill>
           <a:srgbClr val="F5FBF7"/>
         </a:solidFill>
+        <a:effectLst/>
       </p:bgPr>
     </p:bg>
     <p:spTree>
@@ -17756,7 +17445,7 @@
           <a:bodyPr wrap="square" rtlCol="0" anchor="ctr"/>
           <a:lstStyle/>
           <a:p>
-            <a:pPr indent="0" marL="0">
+            <a:pPr marL="0" indent="0">
               <a:buNone/>
             </a:pPr>
             <a:r>
@@ -17795,7 +17484,7 @@
           <a:bodyPr wrap="square" rtlCol="0" anchor="ctr"/>
           <a:lstStyle/>
           <a:p>
-            <a:pPr indent="0" marL="0">
+            <a:pPr marL="0" indent="0">
               <a:buNone/>
             </a:pPr>
             <a:r>
@@ -17922,7 +17611,7 @@
             <a:prstDash val="solid"/>
           </a:ln>
           <a:effectLst>
-            <a:outerShdw sx="100000" sy="100000" kx="0" ky="0" algn="bl" rotWithShape="0" blurRad="101600" dist="38100" dir="8100000">
+            <a:outerShdw blurRad="101600" dist="38100" dir="8100000" algn="bl" rotWithShape="0">
               <a:srgbClr val="000000">
                 <a:alpha val="25000"/>
               </a:srgbClr>
@@ -17951,7 +17640,7 @@
           <a:bodyPr wrap="square" rtlCol="0" anchor="ctr"/>
           <a:lstStyle/>
           <a:p>
-            <a:pPr indent="0" marL="0">
+            <a:pPr marL="0" indent="0">
               <a:buNone/>
             </a:pPr>
             <a:r>
@@ -17968,7 +17657,7 @@
             <a:endParaRPr lang="en-US" sz="950" dirty="0"/>
           </a:p>
           <a:p>
-            <a:pPr indent="0" marL="0">
+            <a:pPr marL="0" indent="0">
               <a:buNone/>
             </a:pPr>
             <a:r>
@@ -17985,7 +17674,7 @@
             <a:endParaRPr lang="en-US" sz="950" dirty="0"/>
           </a:p>
           <a:p>
-            <a:pPr indent="0" marL="0">
+            <a:pPr marL="0" indent="0">
               <a:buNone/>
             </a:pPr>
             <a:r>
@@ -18002,7 +17691,7 @@
             <a:endParaRPr lang="en-US" sz="950" dirty="0"/>
           </a:p>
           <a:p>
-            <a:pPr indent="0" marL="0">
+            <a:pPr marL="0" indent="0">
               <a:buNone/>
             </a:pPr>
             <a:r>
@@ -18019,7 +17708,7 @@
             <a:endParaRPr lang="en-US" sz="950" dirty="0"/>
           </a:p>
           <a:p>
-            <a:pPr indent="0" marL="0">
+            <a:pPr marL="0" indent="0">
               <a:buNone/>
             </a:pPr>
             <a:r>
@@ -18036,7 +17725,7 @@
             <a:endParaRPr lang="en-US" sz="950" dirty="0"/>
           </a:p>
           <a:p>
-            <a:pPr indent="0" marL="0">
+            <a:pPr marL="0" indent="0">
               <a:buNone/>
             </a:pPr>
             <a:r>
@@ -18100,7 +17789,7 @@
           <a:bodyPr wrap="square" rtlCol="0" anchor="ctr"/>
           <a:lstStyle/>
           <a:p>
-            <a:pPr indent="0" marL="0">
+            <a:pPr marL="0" indent="0">
               <a:buNone/>
             </a:pPr>
             <a:r>
@@ -18134,6 +17823,7 @@
         <a:solidFill>
           <a:srgbClr val="F5FBF7"/>
         </a:solidFill>
+        <a:effectLst/>
       </p:bgPr>
     </p:bg>
     <p:spTree>
@@ -18196,7 +17886,7 @@
           <a:bodyPr wrap="square" rtlCol="0" anchor="ctr"/>
           <a:lstStyle/>
           <a:p>
-            <a:pPr indent="0" marL="0">
+            <a:pPr marL="0" indent="0">
               <a:buNone/>
             </a:pPr>
             <a:r>
@@ -18235,7 +17925,7 @@
           <a:bodyPr wrap="square" rtlCol="0" anchor="ctr"/>
           <a:lstStyle/>
           <a:p>
-            <a:pPr indent="0" marL="0">
+            <a:pPr marL="0" indent="0">
               <a:buNone/>
             </a:pPr>
             <a:r>
@@ -18383,7 +18073,7 @@
             <a:prstDash val="solid"/>
           </a:ln>
           <a:effectLst>
-            <a:outerShdw sx="100000" sy="100000" kx="0" ky="0" algn="bl" rotWithShape="0" blurRad="101600" dist="38100" dir="8100000">
+            <a:outerShdw blurRad="101600" dist="38100" dir="8100000" algn="bl" rotWithShape="0">
               <a:srgbClr val="000000">
                 <a:alpha val="25000"/>
               </a:srgbClr>
@@ -18412,7 +18102,7 @@
           <a:bodyPr wrap="square" rtlCol="0" anchor="ctr"/>
           <a:lstStyle/>
           <a:p>
-            <a:pPr indent="0" marL="0">
+            <a:pPr marL="0" indent="0">
               <a:buNone/>
             </a:pPr>
             <a:r>
@@ -18429,7 +18119,7 @@
             <a:endParaRPr lang="en-US" sz="950" dirty="0"/>
           </a:p>
           <a:p>
-            <a:pPr indent="0" marL="0">
+            <a:pPr marL="0" indent="0">
               <a:buNone/>
             </a:pPr>
             <a:r>
@@ -18446,7 +18136,7 @@
             <a:endParaRPr lang="en-US" sz="950" dirty="0"/>
           </a:p>
           <a:p>
-            <a:pPr indent="0" marL="0">
+            <a:pPr marL="0" indent="0">
               <a:buNone/>
             </a:pPr>
             <a:r>
@@ -18463,13 +18153,13 @@
             <a:endParaRPr lang="en-US" sz="950" dirty="0"/>
           </a:p>
           <a:p>
-            <a:pPr indent="0" marL="0">
+            <a:pPr marL="0" indent="0">
               <a:buNone/>
             </a:pPr>
             <a:endParaRPr lang="en-US" sz="950" dirty="0"/>
           </a:p>
           <a:p>
-            <a:pPr indent="0" marL="0">
+            <a:pPr marL="0" indent="0">
               <a:buNone/>
             </a:pPr>
             <a:r>
@@ -18486,7 +18176,7 @@
             <a:endParaRPr lang="en-US" sz="950" dirty="0"/>
           </a:p>
           <a:p>
-            <a:pPr indent="0" marL="0">
+            <a:pPr marL="0" indent="0">
               <a:buNone/>
             </a:pPr>
             <a:r>
@@ -18503,7 +18193,7 @@
             <a:endParaRPr lang="en-US" sz="950" dirty="0"/>
           </a:p>
           <a:p>
-            <a:pPr indent="0" marL="0">
+            <a:pPr marL="0" indent="0">
               <a:buNone/>
             </a:pPr>
             <a:r>
@@ -18520,7 +18210,7 @@
             <a:endParaRPr lang="en-US" sz="950" dirty="0"/>
           </a:p>
           <a:p>
-            <a:pPr indent="0" marL="0">
+            <a:pPr marL="0" indent="0">
               <a:buNone/>
             </a:pPr>
             <a:r>
@@ -18537,7 +18227,7 @@
             <a:endParaRPr lang="en-US" sz="950" dirty="0"/>
           </a:p>
           <a:p>
-            <a:pPr indent="0" marL="0">
+            <a:pPr marL="0" indent="0">
               <a:buNone/>
             </a:pPr>
             <a:r>
@@ -18554,7 +18244,7 @@
             <a:endParaRPr lang="en-US" sz="950" dirty="0"/>
           </a:p>
           <a:p>
-            <a:pPr indent="0" marL="0">
+            <a:pPr marL="0" indent="0">
               <a:buNone/>
             </a:pPr>
             <a:r>
@@ -18571,7 +18261,7 @@
             <a:endParaRPr lang="en-US" sz="950" dirty="0"/>
           </a:p>
           <a:p>
-            <a:pPr indent="0" marL="0">
+            <a:pPr marL="0" indent="0">
               <a:buNone/>
             </a:pPr>
             <a:r>
@@ -18605,6 +18295,7 @@
         <a:solidFill>
           <a:srgbClr val="1A3A2A"/>
         </a:solidFill>
+        <a:effectLst/>
       </p:bgPr>
     </p:bg>
     <p:spTree>
@@ -18642,7 +18333,7 @@
           <a:bodyPr wrap="square" rtlCol="0" anchor="ctr"/>
           <a:lstStyle/>
           <a:p>
-            <a:pPr indent="0" marL="0">
+            <a:pPr marL="0" indent="0">
               <a:buNone/>
             </a:pPr>
             <a:r>
@@ -18681,11 +18372,11 @@
           <a:bodyPr wrap="square" rtlCol="0" anchor="ctr"/>
           <a:lstStyle/>
           <a:p>
-            <a:pPr indent="0" marL="0">
-              <a:buNone/>
-            </a:pPr>
-            <a:r>
-              <a:rPr lang="en-US" sz="900" b="1" spc="400" kern="0" dirty="0">
+            <a:pPr marL="0" indent="0">
+              <a:buNone/>
+            </a:pPr>
+            <a:r>
+              <a:rPr lang="en-US" sz="900" b="1" kern="0" spc="400" dirty="0">
                 <a:solidFill>
                   <a:srgbClr val="A8D8B0"/>
                 </a:solidFill>
@@ -18720,7 +18411,7 @@
           <a:bodyPr wrap="square" rtlCol="0" anchor="ctr"/>
           <a:lstStyle/>
           <a:p>
-            <a:pPr indent="0" marL="0">
+            <a:pPr marL="0" indent="0">
               <a:buNone/>
             </a:pPr>
             <a:r>
@@ -18759,7 +18450,7 @@
           <a:bodyPr wrap="square" rtlCol="0" anchor="ctr"/>
           <a:lstStyle/>
           <a:p>
-            <a:pPr indent="0" marL="0">
+            <a:pPr marL="0" indent="0">
               <a:buNone/>
             </a:pPr>
             <a:r>
@@ -18798,7 +18489,7 @@
           <a:bodyPr wrap="square" rtlCol="0" anchor="ctr"/>
           <a:lstStyle/>
           <a:p>
-            <a:pPr indent="0" marL="0">
+            <a:pPr marL="0" indent="0">
               <a:buNone/>
             </a:pPr>
             <a:r>
@@ -18832,6 +18523,7 @@
         <a:solidFill>
           <a:srgbClr val="F5FBF7"/>
         </a:solidFill>
+        <a:effectLst/>
       </p:bgPr>
     </p:bg>
     <p:spTree>
@@ -18894,7 +18586,7 @@
           <a:bodyPr wrap="square" rtlCol="0" anchor="ctr"/>
           <a:lstStyle/>
           <a:p>
-            <a:pPr indent="0" marL="0">
+            <a:pPr marL="0" indent="0">
               <a:buNone/>
             </a:pPr>
             <a:r>
@@ -18933,7 +18625,7 @@
           <a:bodyPr wrap="square" rtlCol="0" anchor="ctr"/>
           <a:lstStyle/>
           <a:p>
-            <a:pPr indent="0" marL="0">
+            <a:pPr marL="0" indent="0">
               <a:buNone/>
             </a:pPr>
             <a:r>
@@ -19065,8 +18757,8 @@
         </p:nvSpPr>
         <p:spPr>
           <a:xfrm>
-            <a:off x="411480" y="2395728"/>
-            <a:ext cx="8321040" cy="1810512"/>
+            <a:off x="411480" y="2133600"/>
+            <a:ext cx="8321040" cy="2072640"/>
           </a:xfrm>
           <a:prstGeom prst="rect">
             <a:avLst/>
@@ -19081,7 +18773,7 @@
             <a:prstDash val="solid"/>
           </a:ln>
           <a:effectLst>
-            <a:outerShdw sx="100000" sy="100000" kx="0" ky="0" algn="bl" rotWithShape="0" blurRad="101600" dist="38100" dir="8100000">
+            <a:outerShdw blurRad="101600" dist="38100" dir="8100000" algn="bl" rotWithShape="0">
               <a:srgbClr val="000000">
                 <a:alpha val="25000"/>
               </a:srgbClr>
@@ -19097,7 +18789,7 @@
         </p:nvSpPr>
         <p:spPr>
           <a:xfrm>
-            <a:off x="594360" y="2505456"/>
+            <a:off x="640080" y="2377440"/>
             <a:ext cx="7955280" cy="1609344"/>
           </a:xfrm>
           <a:prstGeom prst="rect">
@@ -19110,7 +18802,7 @@
           <a:bodyPr wrap="square" rtlCol="0" anchor="ctr"/>
           <a:lstStyle/>
           <a:p>
-            <a:pPr indent="0" marL="0">
+            <a:pPr marL="0" indent="0">
               <a:buNone/>
             </a:pPr>
             <a:r>
@@ -19127,7 +18819,7 @@
             <a:endParaRPr lang="en-US" sz="950" dirty="0"/>
           </a:p>
           <a:p>
-            <a:pPr indent="0" marL="0">
+            <a:pPr marL="0" indent="0">
               <a:buNone/>
             </a:pPr>
             <a:r>
@@ -19144,7 +18836,7 @@
             <a:endParaRPr lang="en-US" sz="950" dirty="0"/>
           </a:p>
           <a:p>
-            <a:pPr indent="0" marL="0">
+            <a:pPr marL="0" indent="0">
               <a:buNone/>
             </a:pPr>
             <a:r>
@@ -19161,13 +18853,13 @@
             <a:endParaRPr lang="en-US" sz="950" dirty="0"/>
           </a:p>
           <a:p>
-            <a:pPr indent="0" marL="0">
+            <a:pPr marL="0" indent="0">
               <a:buNone/>
             </a:pPr>
             <a:endParaRPr lang="en-US" sz="950" dirty="0"/>
           </a:p>
           <a:p>
-            <a:pPr indent="0" marL="0">
+            <a:pPr marL="0" indent="0">
               <a:buNone/>
             </a:pPr>
             <a:r>
@@ -19184,7 +18876,7 @@
             <a:endParaRPr lang="en-US" sz="950" dirty="0"/>
           </a:p>
           <a:p>
-            <a:pPr indent="0" marL="0">
+            <a:pPr marL="0" indent="0">
               <a:buNone/>
             </a:pPr>
             <a:r>
@@ -19201,13 +18893,13 @@
             <a:endParaRPr lang="en-US" sz="950" dirty="0"/>
           </a:p>
           <a:p>
-            <a:pPr indent="0" marL="0">
+            <a:pPr marL="0" indent="0">
               <a:buNone/>
             </a:pPr>
             <a:endParaRPr lang="en-US" sz="950" dirty="0"/>
           </a:p>
           <a:p>
-            <a:pPr indent="0" marL="0">
+            <a:pPr marL="0" indent="0">
               <a:buNone/>
             </a:pPr>
             <a:r>
@@ -19224,7 +18916,7 @@
             <a:endParaRPr lang="en-US" sz="950" dirty="0"/>
           </a:p>
           <a:p>
-            <a:pPr indent="0" marL="0">
+            <a:pPr marL="0" indent="0">
               <a:buNone/>
             </a:pPr>
             <a:r>
@@ -19241,7 +18933,7 @@
             <a:endParaRPr lang="en-US" sz="950" dirty="0"/>
           </a:p>
           <a:p>
-            <a:pPr indent="0" marL="0">
+            <a:pPr marL="0" indent="0">
               <a:buNone/>
             </a:pPr>
             <a:r>
@@ -19258,7 +18950,7 @@
             <a:endParaRPr lang="en-US" sz="950" dirty="0"/>
           </a:p>
           <a:p>
-            <a:pPr indent="0" marL="0">
+            <a:pPr marL="0" indent="0">
               <a:buNone/>
             </a:pPr>
             <a:r>
@@ -19275,7 +18967,7 @@
             <a:endParaRPr lang="en-US" sz="950" dirty="0"/>
           </a:p>
           <a:p>
-            <a:pPr indent="0" marL="0">
+            <a:pPr marL="0" indent="0">
               <a:buNone/>
             </a:pPr>
             <a:r>
@@ -19292,7 +18984,7 @@
             <a:endParaRPr lang="en-US" sz="950" dirty="0"/>
           </a:p>
           <a:p>
-            <a:pPr indent="0" marL="0">
+            <a:pPr marL="0" indent="0">
               <a:buNone/>
             </a:pPr>
             <a:r>
@@ -19356,7 +19048,7 @@
           <a:bodyPr wrap="square" rtlCol="0" anchor="ctr"/>
           <a:lstStyle/>
           <a:p>
-            <a:pPr indent="0" marL="0">
+            <a:pPr marL="0" indent="0">
               <a:buNone/>
             </a:pPr>
             <a:r>
@@ -19390,6 +19082,7 @@
         <a:solidFill>
           <a:srgbClr val="F5FBF7"/>
         </a:solidFill>
+        <a:effectLst/>
       </p:bgPr>
     </p:bg>
     <p:spTree>
@@ -19452,7 +19145,7 @@
           <a:bodyPr wrap="square" rtlCol="0" anchor="ctr"/>
           <a:lstStyle/>
           <a:p>
-            <a:pPr indent="0" marL="0">
+            <a:pPr marL="0" indent="0">
               <a:buNone/>
             </a:pPr>
             <a:r>
@@ -19491,7 +19184,7 @@
           <a:bodyPr wrap="square" rtlCol="0" anchor="ctr"/>
           <a:lstStyle/>
           <a:p>
-            <a:pPr indent="0" marL="0">
+            <a:pPr marL="0" indent="0">
               <a:buNone/>
             </a:pPr>
             <a:r>
@@ -19639,7 +19332,7 @@
             <a:prstDash val="solid"/>
           </a:ln>
           <a:effectLst>
-            <a:outerShdw sx="100000" sy="100000" kx="0" ky="0" algn="bl" rotWithShape="0" blurRad="101600" dist="38100" dir="8100000">
+            <a:outerShdw blurRad="101600" dist="38100" dir="8100000" algn="bl" rotWithShape="0">
               <a:srgbClr val="000000">
                 <a:alpha val="25000"/>
               </a:srgbClr>
@@ -19668,7 +19361,7 @@
           <a:bodyPr wrap="square" rtlCol="0" anchor="ctr"/>
           <a:lstStyle/>
           <a:p>
-            <a:pPr indent="0" marL="0">
+            <a:pPr marL="0" indent="0">
               <a:buNone/>
             </a:pPr>
             <a:r>
@@ -19685,7 +19378,7 @@
             <a:endParaRPr lang="en-US" sz="950" dirty="0"/>
           </a:p>
           <a:p>
-            <a:pPr indent="0" marL="0">
+            <a:pPr marL="0" indent="0">
               <a:buNone/>
             </a:pPr>
             <a:r>
@@ -19702,13 +19395,13 @@
             <a:endParaRPr lang="en-US" sz="950" dirty="0"/>
           </a:p>
           <a:p>
-            <a:pPr indent="0" marL="0">
+            <a:pPr marL="0" indent="0">
               <a:buNone/>
             </a:pPr>
             <a:endParaRPr lang="en-US" sz="950" dirty="0"/>
           </a:p>
           <a:p>
-            <a:pPr indent="0" marL="0">
+            <a:pPr marL="0" indent="0">
               <a:buNone/>
             </a:pPr>
             <a:r>
@@ -19725,7 +19418,7 @@
             <a:endParaRPr lang="en-US" sz="950" dirty="0"/>
           </a:p>
           <a:p>
-            <a:pPr indent="0" marL="0">
+            <a:pPr marL="0" indent="0">
               <a:buNone/>
             </a:pPr>
             <a:r>
@@ -19742,7 +19435,7 @@
             <a:endParaRPr lang="en-US" sz="950" dirty="0"/>
           </a:p>
           <a:p>
-            <a:pPr indent="0" marL="0">
+            <a:pPr marL="0" indent="0">
               <a:buNone/>
             </a:pPr>
             <a:r>
@@ -19759,7 +19452,7 @@
             <a:endParaRPr lang="en-US" sz="950" dirty="0"/>
           </a:p>
           <a:p>
-            <a:pPr indent="0" marL="0">
+            <a:pPr marL="0" indent="0">
               <a:buNone/>
             </a:pPr>
             <a:r>
@@ -19776,7 +19469,7 @@
             <a:endParaRPr lang="en-US" sz="950" dirty="0"/>
           </a:p>
           <a:p>
-            <a:pPr indent="0" marL="0">
+            <a:pPr marL="0" indent="0">
               <a:buNone/>
             </a:pPr>
             <a:r>
@@ -19793,7 +19486,7 @@
             <a:endParaRPr lang="en-US" sz="950" dirty="0"/>
           </a:p>
           <a:p>
-            <a:pPr indent="0" marL="0">
+            <a:pPr marL="0" indent="0">
               <a:buNone/>
             </a:pPr>
             <a:r>
@@ -19810,7 +19503,7 @@
             <a:endParaRPr lang="en-US" sz="950" dirty="0"/>
           </a:p>
           <a:p>
-            <a:pPr indent="0" marL="0">
+            <a:pPr marL="0" indent="0">
               <a:buNone/>
             </a:pPr>
             <a:r>
@@ -19827,7 +19520,7 @@
             <a:endParaRPr lang="en-US" sz="950" dirty="0"/>
           </a:p>
           <a:p>
-            <a:pPr indent="0" marL="0">
+            <a:pPr marL="0" indent="0">
               <a:buNone/>
             </a:pPr>
             <a:r>
@@ -19844,7 +19537,7 @@
             <a:endParaRPr lang="en-US" sz="950" dirty="0"/>
           </a:p>
           <a:p>
-            <a:pPr indent="0" marL="0">
+            <a:pPr marL="0" indent="0">
               <a:buNone/>
             </a:pPr>
             <a:r>
@@ -19908,7 +19601,7 @@
           <a:bodyPr wrap="square" rtlCol="0" anchor="ctr"/>
           <a:lstStyle/>
           <a:p>
-            <a:pPr indent="0" marL="0">
+            <a:pPr marL="0" indent="0">
               <a:buNone/>
             </a:pPr>
             <a:r>
@@ -20227,4 +19920,299 @@
     </a:ext>
   </a:extLst>
 </a:theme>
+</file>
+
+<file path=ppt/theme/theme2.xml><?xml version="1.0" encoding="utf-8"?>
+<a:theme xmlns:a="http://schemas.openxmlformats.org/drawingml/2006/main" name="Tema do Office">
+  <a:themeElements>
+    <a:clrScheme name="Office">
+      <a:dk1>
+        <a:sysClr val="windowText" lastClr="000000"/>
+      </a:dk1>
+      <a:lt1>
+        <a:sysClr val="window" lastClr="FFFFFF"/>
+      </a:lt1>
+      <a:dk2>
+        <a:srgbClr val="44546A"/>
+      </a:dk2>
+      <a:lt2>
+        <a:srgbClr val="E7E6E6"/>
+      </a:lt2>
+      <a:accent1>
+        <a:srgbClr val="4472C4"/>
+      </a:accent1>
+      <a:accent2>
+        <a:srgbClr val="ED7D31"/>
+      </a:accent2>
+      <a:accent3>
+        <a:srgbClr val="A5A5A5"/>
+      </a:accent3>
+      <a:accent4>
+        <a:srgbClr val="FFC000"/>
+      </a:accent4>
+      <a:accent5>
+        <a:srgbClr val="5B9BD5"/>
+      </a:accent5>
+      <a:accent6>
+        <a:srgbClr val="70AD47"/>
+      </a:accent6>
+      <a:hlink>
+        <a:srgbClr val="0563C1"/>
+      </a:hlink>
+      <a:folHlink>
+        <a:srgbClr val="954F72"/>
+      </a:folHlink>
+    </a:clrScheme>
+    <a:fontScheme name="Office">
+      <a:majorFont>
+        <a:latin typeface="Calibri Light" panose="020F0302020204030204"/>
+        <a:ea typeface=""/>
+        <a:cs typeface=""/>
+        <a:font script="Jpan" typeface="游ゴシック Light"/>
+        <a:font script="Hang" typeface="맑은 고딕"/>
+        <a:font script="Hans" typeface="等线 Light"/>
+        <a:font script="Hant" typeface="新細明體"/>
+        <a:font script="Arab" typeface="Times New Roman"/>
+        <a:font script="Hebr" typeface="Times New Roman"/>
+        <a:font script="Thai" typeface="Angsana New"/>
+        <a:font script="Ethi" typeface="Nyala"/>
+        <a:font script="Beng" typeface="Vrinda"/>
+        <a:font script="Gujr" typeface="Shruti"/>
+        <a:font script="Khmr" typeface="MoolBoran"/>
+        <a:font script="Knda" typeface="Tunga"/>
+        <a:font script="Guru" typeface="Raavi"/>
+        <a:font script="Cans" typeface="Euphemia"/>
+        <a:font script="Cher" typeface="Plantagenet Cherokee"/>
+        <a:font script="Yiii" typeface="Microsoft Yi Baiti"/>
+        <a:font script="Tibt" typeface="Microsoft Himalaya"/>
+        <a:font script="Thaa" typeface="MV Boli"/>
+        <a:font script="Deva" typeface="Mangal"/>
+        <a:font script="Telu" typeface="Gautami"/>
+        <a:font script="Taml" typeface="Latha"/>
+        <a:font script="Syrc" typeface="Estrangelo Edessa"/>
+        <a:font script="Orya" typeface="Kalinga"/>
+        <a:font script="Mlym" typeface="Kartika"/>
+        <a:font script="Laoo" typeface="DokChampa"/>
+        <a:font script="Sinh" typeface="Iskoola Pota"/>
+        <a:font script="Mong" typeface="Mongolian Baiti"/>
+        <a:font script="Viet" typeface="Times New Roman"/>
+        <a:font script="Uigh" typeface="Microsoft Uighur"/>
+        <a:font script="Geor" typeface="Sylfaen"/>
+        <a:font script="Armn" typeface="Arial"/>
+        <a:font script="Bugi" typeface="Leelawadee UI"/>
+        <a:font script="Bopo" typeface="Microsoft JhengHei"/>
+        <a:font script="Java" typeface="Javanese Text"/>
+        <a:font script="Lisu" typeface="Segoe UI"/>
+        <a:font script="Mymr" typeface="Myanmar Text"/>
+        <a:font script="Nkoo" typeface="Ebrima"/>
+        <a:font script="Olck" typeface="Nirmala UI"/>
+        <a:font script="Osma" typeface="Ebrima"/>
+        <a:font script="Phag" typeface="Phagspa"/>
+        <a:font script="Syrn" typeface="Estrangelo Edessa"/>
+        <a:font script="Syrj" typeface="Estrangelo Edessa"/>
+        <a:font script="Syre" typeface="Estrangelo Edessa"/>
+        <a:font script="Sora" typeface="Nirmala UI"/>
+        <a:font script="Tale" typeface="Microsoft Tai Le"/>
+        <a:font script="Talu" typeface="Microsoft New Tai Lue"/>
+        <a:font script="Tfng" typeface="Ebrima"/>
+      </a:majorFont>
+      <a:minorFont>
+        <a:latin typeface="Calibri" panose="020F0502020204030204"/>
+        <a:ea typeface=""/>
+        <a:cs typeface=""/>
+        <a:font script="Jpan" typeface="游ゴシック"/>
+        <a:font script="Hang" typeface="맑은 고딕"/>
+        <a:font script="Hans" typeface="等线"/>
+        <a:font script="Hant" typeface="新細明體"/>
+        <a:font script="Arab" typeface="Arial"/>
+        <a:font script="Hebr" typeface="Arial"/>
+        <a:font script="Thai" typeface="Cordia New"/>
+        <a:font script="Ethi" typeface="Nyala"/>
+        <a:font script="Beng" typeface="Vrinda"/>
+        <a:font script="Gujr" typeface="Shruti"/>
+        <a:font script="Khmr" typeface="DaunPenh"/>
+        <a:font script="Knda" typeface="Tunga"/>
+        <a:font script="Guru" typeface="Raavi"/>
+        <a:font script="Cans" typeface="Euphemia"/>
+        <a:font script="Cher" typeface="Plantagenet Cherokee"/>
+        <a:font script="Yiii" typeface="Microsoft Yi Baiti"/>
+        <a:font script="Tibt" typeface="Microsoft Himalaya"/>
+        <a:font script="Thaa" typeface="MV Boli"/>
+        <a:font script="Deva" typeface="Mangal"/>
+        <a:font script="Telu" typeface="Gautami"/>
+        <a:font script="Taml" typeface="Latha"/>
+        <a:font script="Syrc" typeface="Estrangelo Edessa"/>
+        <a:font script="Orya" typeface="Kalinga"/>
+        <a:font script="Mlym" typeface="Kartika"/>
+        <a:font script="Laoo" typeface="DokChampa"/>
+        <a:font script="Sinh" typeface="Iskoola Pota"/>
+        <a:font script="Mong" typeface="Mongolian Baiti"/>
+        <a:font script="Viet" typeface="Arial"/>
+        <a:font script="Uigh" typeface="Microsoft Uighur"/>
+        <a:font script="Geor" typeface="Sylfaen"/>
+        <a:font script="Armn" typeface="Arial"/>
+        <a:font script="Bugi" typeface="Leelawadee UI"/>
+        <a:font script="Bopo" typeface="Microsoft JhengHei"/>
+        <a:font script="Java" typeface="Javanese Text"/>
+        <a:font script="Lisu" typeface="Segoe UI"/>
+        <a:font script="Mymr" typeface="Myanmar Text"/>
+        <a:font script="Nkoo" typeface="Ebrima"/>
+        <a:font script="Olck" typeface="Nirmala UI"/>
+        <a:font script="Osma" typeface="Ebrima"/>
+        <a:font script="Phag" typeface="Phagspa"/>
+        <a:font script="Syrn" typeface="Estrangelo Edessa"/>
+        <a:font script="Syrj" typeface="Estrangelo Edessa"/>
+        <a:font script="Syre" typeface="Estrangelo Edessa"/>
+        <a:font script="Sora" typeface="Nirmala UI"/>
+        <a:font script="Tale" typeface="Microsoft Tai Le"/>
+        <a:font script="Talu" typeface="Microsoft New Tai Lue"/>
+        <a:font script="Tfng" typeface="Ebrima"/>
+      </a:minorFont>
+    </a:fontScheme>
+    <a:fmtScheme name="Office">
+      <a:fillStyleLst>
+        <a:solidFill>
+          <a:schemeClr val="phClr"/>
+        </a:solidFill>
+        <a:gradFill rotWithShape="1">
+          <a:gsLst>
+            <a:gs pos="0">
+              <a:schemeClr val="phClr">
+                <a:lumMod val="110000"/>
+                <a:satMod val="105000"/>
+                <a:tint val="67000"/>
+              </a:schemeClr>
+            </a:gs>
+            <a:gs pos="50000">
+              <a:schemeClr val="phClr">
+                <a:lumMod val="105000"/>
+                <a:satMod val="103000"/>
+                <a:tint val="73000"/>
+              </a:schemeClr>
+            </a:gs>
+            <a:gs pos="100000">
+              <a:schemeClr val="phClr">
+                <a:lumMod val="105000"/>
+                <a:satMod val="109000"/>
+                <a:tint val="81000"/>
+              </a:schemeClr>
+            </a:gs>
+          </a:gsLst>
+          <a:lin ang="5400000" scaled="0"/>
+        </a:gradFill>
+        <a:gradFill rotWithShape="1">
+          <a:gsLst>
+            <a:gs pos="0">
+              <a:schemeClr val="phClr">
+                <a:satMod val="103000"/>
+                <a:lumMod val="102000"/>
+                <a:tint val="94000"/>
+              </a:schemeClr>
+            </a:gs>
+            <a:gs pos="50000">
+              <a:schemeClr val="phClr">
+                <a:satMod val="110000"/>
+                <a:lumMod val="100000"/>
+                <a:shade val="100000"/>
+              </a:schemeClr>
+            </a:gs>
+            <a:gs pos="100000">
+              <a:schemeClr val="phClr">
+                <a:lumMod val="99000"/>
+                <a:satMod val="120000"/>
+                <a:shade val="78000"/>
+              </a:schemeClr>
+            </a:gs>
+          </a:gsLst>
+          <a:lin ang="5400000" scaled="0"/>
+        </a:gradFill>
+      </a:fillStyleLst>
+      <a:lnStyleLst>
+        <a:ln w="6350" cap="flat" cmpd="sng" algn="ctr">
+          <a:solidFill>
+            <a:schemeClr val="phClr"/>
+          </a:solidFill>
+          <a:prstDash val="solid"/>
+          <a:miter lim="800000"/>
+        </a:ln>
+        <a:ln w="12700" cap="flat" cmpd="sng" algn="ctr">
+          <a:solidFill>
+            <a:schemeClr val="phClr"/>
+          </a:solidFill>
+          <a:prstDash val="solid"/>
+          <a:miter lim="800000"/>
+        </a:ln>
+        <a:ln w="19050" cap="flat" cmpd="sng" algn="ctr">
+          <a:solidFill>
+            <a:schemeClr val="phClr"/>
+          </a:solidFill>
+          <a:prstDash val="solid"/>
+          <a:miter lim="800000"/>
+        </a:ln>
+      </a:lnStyleLst>
+      <a:effectStyleLst>
+        <a:effectStyle>
+          <a:effectLst/>
+        </a:effectStyle>
+        <a:effectStyle>
+          <a:effectLst/>
+        </a:effectStyle>
+        <a:effectStyle>
+          <a:effectLst>
+            <a:outerShdw blurRad="57150" dist="19050" dir="5400000" algn="ctr" rotWithShape="0">
+              <a:srgbClr val="000000">
+                <a:alpha val="63000"/>
+              </a:srgbClr>
+            </a:outerShdw>
+          </a:effectLst>
+        </a:effectStyle>
+      </a:effectStyleLst>
+      <a:bgFillStyleLst>
+        <a:solidFill>
+          <a:schemeClr val="phClr"/>
+        </a:solidFill>
+        <a:solidFill>
+          <a:schemeClr val="phClr">
+            <a:tint val="95000"/>
+            <a:satMod val="170000"/>
+          </a:schemeClr>
+        </a:solidFill>
+        <a:gradFill rotWithShape="1">
+          <a:gsLst>
+            <a:gs pos="0">
+              <a:schemeClr val="phClr">
+                <a:tint val="93000"/>
+                <a:satMod val="150000"/>
+                <a:shade val="98000"/>
+                <a:lumMod val="102000"/>
+              </a:schemeClr>
+            </a:gs>
+            <a:gs pos="50000">
+              <a:schemeClr val="phClr">
+                <a:tint val="98000"/>
+                <a:satMod val="130000"/>
+                <a:shade val="90000"/>
+                <a:lumMod val="103000"/>
+              </a:schemeClr>
+            </a:gs>
+            <a:gs pos="100000">
+              <a:schemeClr val="phClr">
+                <a:shade val="63000"/>
+                <a:satMod val="120000"/>
+              </a:schemeClr>
+            </a:gs>
+          </a:gsLst>
+          <a:lin ang="5400000" scaled="0"/>
+        </a:gradFill>
+      </a:bgFillStyleLst>
+    </a:fmtScheme>
+  </a:themeElements>
+  <a:objectDefaults/>
+  <a:extraClrSchemeLst/>
+  <a:extLst>
+    <a:ext uri="{05A4C25C-085E-4340-85A3-A5531E510DB2}">
+      <thm15:themeFamily xmlns:thm15="http://schemas.microsoft.com/office/thememl/2012/main" name="Office Theme" id="{62F939B6-93AF-4DB8-9C6B-D6C7DFDC589F}" vid="{4A3C46E8-61CC-4603-A589-7422A47A8E4A}"/>
+    </a:ext>
+  </a:extLst>
+</a:theme>
 </file>
</xml_diff>